<commit_message>
Constraint issue on iPhones with dynamic islands fixed and updates on presentation
</commit_message>
<xml_diff>
--- a/presentation/MoodStreak.pptx
+++ b/presentation/MoodStreak.pptx
@@ -4,6 +4,9 @@
   <p:sldMasterIdLst>
     <p:sldMasterId id="2147483648" r:id="rId1"/>
   </p:sldMasterIdLst>
+  <p:notesMasterIdLst>
+    <p:notesMasterId r:id="rId12"/>
+  </p:notesMasterIdLst>
   <p:sldIdLst>
     <p:sldId id="256" r:id="rId2"/>
     <p:sldId id="257" r:id="rId3"/>
@@ -16,10 +19,7 @@
     <p:sldId id="264" r:id="rId10"/>
     <p:sldId id="265" r:id="rId11"/>
   </p:sldIdLst>
-  <p:notesMasterIdLst>
-    <p:notesMasterId r:id="rId12"/>
-  </p:notesMasterIdLst>
-  <p:sldSz cx="9144000" cy="5143500"/>
+  <p:sldSz cx="9144000" cy="5143500" type="screen16x9"/>
   <p:notesSz cx="5143500" cy="9144000"/>
   <p:defaultTextStyle>
     <a:lvl1pPr marL="0" algn="l" defTabSz="914400" rtl="0" eaLnBrk="1" latinLnBrk="0" hangingPunct="1">
@@ -113,6 +113,11 @@
       </a:defRPr>
     </a:lvl9pPr>
   </p:defaultTextStyle>
+  <p:extLst>
+    <p:ext uri="{EFAFB233-063F-42B5-8137-9DF3F51BA10A}">
+      <p15:sldGuideLst xmlns:p15="http://schemas.microsoft.com/office/powerpoint/2012/main"/>
+    </p:ext>
+  </p:extLst>
 </p:presentation>
 </file>
 
@@ -138,234 +143,10 @@
           <a:chExt cx="0" cy="0"/>
         </a:xfrm>
       </p:grpSpPr>
-      <p:sp>
-        <p:nvSpPr>
-          <p:cNvPr id="2" name="Header Placeholder 1"/>
-          <p:cNvSpPr>
-            <a:spLocks noGrp="1"/>
-          </p:cNvSpPr>
-          <p:nvPr>
-            <p:ph type="hdr" sz="quarter"/>
-          </p:nvPr>
-        </p:nvSpPr>
-        <p:spPr>
-          <a:xfrm>
-            <a:off x="0" y="0"/>
-            <a:ext cx="2971800" cy="458788"/>
-          </a:xfrm>
-          <a:prstGeom prst="rect">
-            <a:avLst/>
-          </a:prstGeom>
-        </p:spPr>
-        <p:txBody>
-          <a:bodyPr vert="horz" lIns="91440" tIns="45720" rIns="91440" bIns="45720" rtlCol="0"/>
-          <a:lstStyle>
-            <a:lvl1pPr algn="l">
-              <a:defRPr sz="1200"/>
-            </a:lvl1pPr>
-          </a:lstStyle>
-          <a:p>
-            <a:endParaRPr lang="en-US"/>
-          </a:p>
-        </p:txBody>
-      </p:sp>
-      <p:sp>
-        <p:nvSpPr>
-          <p:cNvPr id="3" name="Date Placeholder 2"/>
-          <p:cNvSpPr>
-            <a:spLocks noGrp="1"/>
-          </p:cNvSpPr>
-          <p:nvPr>
-            <p:ph type="dt" idx="1"/>
-          </p:nvPr>
-        </p:nvSpPr>
-        <p:spPr>
-          <a:xfrm>
-            <a:off x="3884613" y="0"/>
-            <a:ext cx="2971800" cy="458788"/>
-          </a:xfrm>
-          <a:prstGeom prst="rect">
-            <a:avLst/>
-          </a:prstGeom>
-        </p:spPr>
-        <p:txBody>
-          <a:bodyPr vert="horz" lIns="91440" tIns="45720" rIns="91440" bIns="45720" rtlCol="0"/>
-          <a:lstStyle>
-            <a:lvl1pPr algn="r">
-              <a:defRPr sz="1200"/>
-            </a:lvl1pPr>
-          </a:lstStyle>
-          <a:p>
-            <a:fld id="{5282F153-3F37-0F45-9E97-73ACFA13230C}" type="datetimeFigureOut">
-              <a:rPr lang="en-US"/>
-              <a:t>7/23/19</a:t>
-            </a:fld>
-            <a:endParaRPr lang="en-US"/>
-          </a:p>
-        </p:txBody>
-      </p:sp>
-      <p:sp>
-        <p:nvSpPr>
-          <p:cNvPr id="4" name="Slide Image Placeholder 3"/>
-          <p:cNvSpPr>
-            <a:spLocks noGrp="1" noRot="1" noChangeAspect="1"/>
-          </p:cNvSpPr>
-          <p:nvPr>
-            <p:ph type="sldImg" idx="2"/>
-          </p:nvPr>
-        </p:nvSpPr>
-        <p:spPr>
-          <a:xfrm>
-            <a:off x="685800" y="1143000"/>
-            <a:ext cx="5486400" cy="3086100"/>
-          </a:xfrm>
-          <a:prstGeom prst="rect">
-            <a:avLst/>
-          </a:prstGeom>
-          <a:noFill/>
-          <a:ln w="12700">
-            <a:solidFill>
-              <a:prstClr val="black"/>
-            </a:solidFill>
-          </a:ln>
-        </p:spPr>
-        <p:txBody>
-          <a:bodyPr vert="horz" lIns="91440" tIns="45720" rIns="91440" bIns="45720" rtlCol="0" anchor="ctr"/>
-          <a:lstStyle/>
-          <a:p>
-            <a:endParaRPr lang="en-US"/>
-          </a:p>
-        </p:txBody>
-      </p:sp>
-      <p:sp>
-        <p:nvSpPr>
-          <p:cNvPr id="5" name="Notes Placeholder 4"/>
-          <p:cNvSpPr>
-            <a:spLocks noGrp="1"/>
-          </p:cNvSpPr>
-          <p:nvPr>
-            <p:ph type="body" sz="quarter" idx="3"/>
-          </p:nvPr>
-        </p:nvSpPr>
-        <p:spPr>
-          <a:xfrm>
-            <a:off x="685800" y="4400550"/>
-            <a:ext cx="5486400" cy="3600450"/>
-          </a:xfrm>
-          <a:prstGeom prst="rect">
-            <a:avLst/>
-          </a:prstGeom>
-        </p:spPr>
-        <p:txBody>
-          <a:bodyPr vert="horz" lIns="91440" tIns="45720" rIns="91440" bIns="45720" rtlCol="0"/>
-          <a:lstStyle/>
-          <a:p>
-            <a:pPr lvl="0"/>
-            <a:r>
-              <a:rPr lang="en-US"/>
-              <a:t>Click to edit Master text styles</a:t>
-            </a:r>
-          </a:p>
-          <a:p>
-            <a:pPr lvl="1"/>
-            <a:r>
-              <a:rPr lang="en-US"/>
-              <a:t>Second level</a:t>
-            </a:r>
-          </a:p>
-          <a:p>
-            <a:pPr lvl="2"/>
-            <a:r>
-              <a:rPr lang="en-US"/>
-              <a:t>Third level</a:t>
-            </a:r>
-          </a:p>
-          <a:p>
-            <a:pPr lvl="3"/>
-            <a:r>
-              <a:rPr lang="en-US"/>
-              <a:t>Fourth level</a:t>
-            </a:r>
-          </a:p>
-          <a:p>
-            <a:pPr lvl="4"/>
-            <a:r>
-              <a:rPr lang="en-US"/>
-              <a:t>Fifth level</a:t>
-            </a:r>
-          </a:p>
-        </p:txBody>
-      </p:sp>
-      <p:sp>
-        <p:nvSpPr>
-          <p:cNvPr id="6" name="Footer Placeholder 5"/>
-          <p:cNvSpPr>
-            <a:spLocks noGrp="1"/>
-          </p:cNvSpPr>
-          <p:nvPr>
-            <p:ph type="ftr" sz="quarter" idx="4"/>
-          </p:nvPr>
-        </p:nvSpPr>
-        <p:spPr>
-          <a:xfrm>
-            <a:off x="0" y="8685213"/>
-            <a:ext cx="2971800" cy="458787"/>
-          </a:xfrm>
-          <a:prstGeom prst="rect">
-            <a:avLst/>
-          </a:prstGeom>
-        </p:spPr>
-        <p:txBody>
-          <a:bodyPr vert="horz" lIns="91440" tIns="45720" rIns="91440" bIns="45720" rtlCol="0" anchor="b"/>
-          <a:lstStyle>
-            <a:lvl1pPr algn="l">
-              <a:defRPr sz="1200"/>
-            </a:lvl1pPr>
-          </a:lstStyle>
-          <a:p>
-            <a:endParaRPr lang="en-US"/>
-          </a:p>
-        </p:txBody>
-      </p:sp>
-      <p:sp>
-        <p:nvSpPr>
-          <p:cNvPr id="7" name="Slide Number Placeholder 6"/>
-          <p:cNvSpPr>
-            <a:spLocks noGrp="1"/>
-          </p:cNvSpPr>
-          <p:nvPr>
-            <p:ph type="sldNum" sz="quarter" idx="5"/>
-          </p:nvPr>
-        </p:nvSpPr>
-        <p:spPr>
-          <a:xfrm>
-            <a:off x="3884613" y="8685213"/>
-            <a:ext cx="2971800" cy="458787"/>
-          </a:xfrm>
-          <a:prstGeom prst="rect">
-            <a:avLst/>
-          </a:prstGeom>
-        </p:spPr>
-        <p:txBody>
-          <a:bodyPr vert="horz" lIns="91440" tIns="45720" rIns="91440" bIns="45720" rtlCol="0" anchor="b"/>
-          <a:lstStyle>
-            <a:lvl1pPr algn="r">
-              <a:defRPr sz="1200"/>
-            </a:lvl1pPr>
-          </a:lstStyle>
-          <a:p>
-            <a:fld id="{CE5E9CC1-C706-0F49-92D6-E571CC5EEA8F}" type="slidenum">
-              <a:rPr lang="en-US"/>
-              <a:t>‹#›</a:t>
-            </a:fld>
-            <a:endParaRPr lang="en-US"/>
-          </a:p>
-        </p:txBody>
-      </p:sp>
     </p:spTree>
     <p:extLst>
       <p:ext uri="{BB962C8B-B14F-4D97-AF65-F5344CB8AC3E}">
-        <p14:creationId xmlns:p14="http://schemas.microsoft.com/office/powerpoint/2010/main" val="1024086991"/>
+        <p14:creationId xmlns:p14="http://schemas.microsoft.com/office/powerpoint/2010/main" val="2495419604"/>
       </p:ext>
     </p:extLst>
   </p:cSld>
@@ -509,10 +290,6 @@
           <a:bodyPr/>
           <a:lstStyle/>
           <a:p>
-            <a:r>
-              <a:rPr lang="en-US" dirty="0"/>
-              <a:t/>
-            </a:r>
             <a:endParaRPr lang="en-US" dirty="0"/>
           </a:p>
         </p:txBody>
@@ -597,10 +374,6 @@
           <a:bodyPr/>
           <a:lstStyle/>
           <a:p>
-            <a:r>
-              <a:rPr lang="en-US" dirty="0"/>
-              <a:t/>
-            </a:r>
             <a:endParaRPr lang="en-US" dirty="0"/>
           </a:p>
         </p:txBody>
@@ -685,10 +458,6 @@
           <a:bodyPr/>
           <a:lstStyle/>
           <a:p>
-            <a:r>
-              <a:rPr lang="en-US" dirty="0"/>
-              <a:t/>
-            </a:r>
             <a:endParaRPr lang="en-US" dirty="0"/>
           </a:p>
         </p:txBody>
@@ -773,10 +542,6 @@
           <a:bodyPr/>
           <a:lstStyle/>
           <a:p>
-            <a:r>
-              <a:rPr lang="en-US" dirty="0"/>
-              <a:t/>
-            </a:r>
             <a:endParaRPr lang="en-US" dirty="0"/>
           </a:p>
         </p:txBody>
@@ -861,10 +626,6 @@
           <a:bodyPr/>
           <a:lstStyle/>
           <a:p>
-            <a:r>
-              <a:rPr lang="en-US" dirty="0"/>
-              <a:t/>
-            </a:r>
             <a:endParaRPr lang="en-US" dirty="0"/>
           </a:p>
         </p:txBody>
@@ -949,10 +710,6 @@
           <a:bodyPr/>
           <a:lstStyle/>
           <a:p>
-            <a:r>
-              <a:rPr lang="en-US" dirty="0"/>
-              <a:t/>
-            </a:r>
             <a:endParaRPr lang="en-US" dirty="0"/>
           </a:p>
         </p:txBody>
@@ -1037,10 +794,6 @@
           <a:bodyPr/>
           <a:lstStyle/>
           <a:p>
-            <a:r>
-              <a:rPr lang="en-US" dirty="0"/>
-              <a:t/>
-            </a:r>
             <a:endParaRPr lang="en-US" dirty="0"/>
           </a:p>
         </p:txBody>
@@ -1125,10 +878,6 @@
           <a:bodyPr/>
           <a:lstStyle/>
           <a:p>
-            <a:r>
-              <a:rPr lang="en-US" dirty="0"/>
-              <a:t/>
-            </a:r>
             <a:endParaRPr lang="en-US" dirty="0"/>
           </a:p>
         </p:txBody>
@@ -1213,10 +962,6 @@
           <a:bodyPr/>
           <a:lstStyle/>
           <a:p>
-            <a:r>
-              <a:rPr lang="en-US" dirty="0"/>
-              <a:t/>
-            </a:r>
             <a:endParaRPr lang="en-US" dirty="0"/>
           </a:p>
         </p:txBody>
@@ -1301,10 +1046,6 @@
           <a:bodyPr/>
           <a:lstStyle/>
           <a:p>
-            <a:r>
-              <a:rPr lang="en-US" dirty="0"/>
-              <a:t/>
-            </a:r>
             <a:endParaRPr lang="en-US" dirty="0"/>
           </a:p>
         </p:txBody>
@@ -1378,6 +1119,11 @@
 <file path=ppt/slideMasters/slideMaster1.xml><?xml version="1.0" encoding="utf-8"?>
 <p:sldMaster xmlns:a="http://schemas.openxmlformats.org/drawingml/2006/main" xmlns:r="http://schemas.openxmlformats.org/officeDocument/2006/relationships" xmlns:p="http://schemas.openxmlformats.org/presentationml/2006/main">
   <p:cSld>
+    <p:bg>
+      <p:bgRef idx="1001">
+        <a:schemeClr val="bg1"/>
+      </p:bgRef>
+    </p:bg>
     <p:spTree>
       <p:nvGrpSpPr>
         <p:cNvPr id="1" name=""/>
@@ -1660,6 +1406,7 @@
         <a:solidFill>
           <a:srgbClr val="6C4CF1"/>
         </a:solidFill>
+        <a:effectLst/>
       </p:bgPr>
     </p:bg>
     <p:spTree>
@@ -1697,7 +1444,7 @@
           <a:bodyPr wrap="square" lIns="0" tIns="0" rIns="0" bIns="0" rtlCol="0" anchor="ctr"/>
           <a:lstStyle/>
           <a:p>
-            <a:pPr indent="0" marL="0">
+            <a:pPr marL="0" indent="0">
               <a:buNone/>
             </a:pPr>
             <a:r>
@@ -1736,7 +1483,7 @@
           <a:bodyPr wrap="square" lIns="0" tIns="0" rIns="0" bIns="0" rtlCol="0" anchor="ctr"/>
           <a:lstStyle/>
           <a:p>
-            <a:pPr indent="0" marL="0">
+            <a:pPr marL="0" indent="0">
               <a:buNone/>
             </a:pPr>
             <a:r>
@@ -1775,7 +1522,7 @@
           <a:bodyPr wrap="square" lIns="0" tIns="0" rIns="0" bIns="0" rtlCol="0" anchor="ctr"/>
           <a:lstStyle/>
           <a:p>
-            <a:pPr indent="0" marL="0">
+            <a:pPr marL="0" indent="0">
               <a:buNone/>
             </a:pPr>
             <a:r>
@@ -1792,7 +1539,7 @@
             <a:endParaRPr lang="en-US" sz="1400" dirty="0"/>
           </a:p>
           <a:p>
-            <a:pPr indent="0" marL="0">
+            <a:pPr marL="0" indent="0">
               <a:buNone/>
             </a:pPr>
             <a:r>
@@ -1804,7 +1551,7 @@
                 <a:ea typeface="Calibri" pitchFamily="34" charset="-122"/>
                 <a:cs typeface="Calibri" pitchFamily="34" charset="-120"/>
               </a:rPr>
-              <a:t>Team: [Name 1] · [Name 2] · [Name 3]</a:t>
+              <a:t>Team: Dasun Priyankara Alagiya Durage (12273809)</a:t>
             </a:r>
             <a:endParaRPr lang="en-US" sz="1400" dirty="0"/>
           </a:p>
@@ -1812,22 +1559,21 @@
       </p:sp>
       <p:pic>
         <p:nvPicPr>
-          <p:cNvPr id="5" name="Image 0" descr="/home/claude/moodstreak/docs/screenshots/03-today.png">    </p:cNvPr>
+          <p:cNvPr id="5" name="Image 0"/>
           <p:cNvPicPr>
             <a:picLocks noChangeAspect="1"/>
           </p:cNvPicPr>
           <p:nvPr/>
         </p:nvPicPr>
         <p:blipFill>
-          <a:blip r:embed="rId1"/>
-          <a:stretch>
-            <a:fillRect/>
-          </a:stretch>
+          <a:blip r:embed="rId3"/>
+          <a:srcRect/>
+          <a:stretch/>
         </p:blipFill>
         <p:spPr>
           <a:xfrm>
-            <a:off x="5486400" y="548640"/>
-            <a:ext cx="1774686" cy="3840480"/>
+            <a:off x="5488750" y="548640"/>
+            <a:ext cx="1769986" cy="3840480"/>
           </a:xfrm>
           <a:prstGeom prst="rect">
             <a:avLst/>
@@ -1836,22 +1582,21 @@
       </p:pic>
       <p:pic>
         <p:nvPicPr>
-          <p:cNvPr id="6" name="Image 1" descr="/home/claude/moodstreak/docs/screenshots/06-insights.png">    </p:cNvPr>
+          <p:cNvPr id="6" name="Image 1"/>
           <p:cNvPicPr>
             <a:picLocks noChangeAspect="1"/>
           </p:cNvPicPr>
           <p:nvPr/>
         </p:nvPicPr>
         <p:blipFill>
-          <a:blip r:embed="rId2"/>
-          <a:stretch>
-            <a:fillRect/>
-          </a:stretch>
+          <a:blip r:embed="rId4"/>
+          <a:srcRect/>
+          <a:stretch/>
         </p:blipFill>
         <p:spPr>
           <a:xfrm>
-            <a:off x="7178040" y="914400"/>
-            <a:ext cx="1774686" cy="3840480"/>
+            <a:off x="7180390" y="914400"/>
+            <a:ext cx="1769986" cy="3840480"/>
           </a:xfrm>
           <a:prstGeom prst="rect">
             <a:avLst/>
@@ -1874,6 +1619,7 @@
         <a:solidFill>
           <a:srgbClr val="FFFFFF"/>
         </a:solidFill>
+        <a:effectLst/>
       </p:bgPr>
     </p:bg>
     <p:spTree>
@@ -1914,6 +1660,13 @@
             <a:prstDash val="solid"/>
           </a:ln>
         </p:spPr>
+        <p:txBody>
+          <a:bodyPr/>
+          <a:lstStyle/>
+          <a:p>
+            <a:endParaRPr lang="en-US"/>
+          </a:p>
+        </p:txBody>
       </p:sp>
       <p:sp>
         <p:nvSpPr>
@@ -1936,7 +1689,7 @@
           <a:bodyPr wrap="square" lIns="0" tIns="0" rIns="0" bIns="0" rtlCol="0" anchor="ctr"/>
           <a:lstStyle/>
           <a:p>
-            <a:pPr indent="0" marL="0">
+            <a:pPr marL="0" indent="0">
               <a:buNone/>
             </a:pPr>
             <a:r>
@@ -1980,6 +1733,13 @@
             <a:prstDash val="solid"/>
           </a:ln>
         </p:spPr>
+        <p:txBody>
+          <a:bodyPr/>
+          <a:lstStyle/>
+          <a:p>
+            <a:endParaRPr lang="en-US"/>
+          </a:p>
+        </p:txBody>
       </p:sp>
       <p:sp>
         <p:nvSpPr>
@@ -2007,6 +1767,13 @@
             <a:prstDash val="solid"/>
           </a:ln>
         </p:spPr>
+        <p:txBody>
+          <a:bodyPr/>
+          <a:lstStyle/>
+          <a:p>
+            <a:endParaRPr lang="en-US"/>
+          </a:p>
+        </p:txBody>
       </p:sp>
       <p:sp>
         <p:nvSpPr>
@@ -2029,7 +1796,7 @@
           <a:bodyPr wrap="square" lIns="0" tIns="0" rIns="0" bIns="0" rtlCol="0" anchor="ctr"/>
           <a:lstStyle/>
           <a:p>
-            <a:pPr indent="0" marL="0">
+            <a:pPr marL="0" indent="0">
               <a:buNone/>
             </a:pPr>
             <a:r>
@@ -2174,7 +1941,7 @@
           <a:bodyPr wrap="square" lIns="0" tIns="0" rIns="0" bIns="0" rtlCol="0" anchor="ctr"/>
           <a:lstStyle/>
           <a:p>
-            <a:pPr indent="0" marL="0">
+            <a:pPr marL="0" indent="0">
               <a:buNone/>
             </a:pPr>
             <a:r>
@@ -2314,6 +2081,7 @@
         <a:solidFill>
           <a:srgbClr val="FFFFFF"/>
         </a:solidFill>
+        <a:effectLst/>
       </p:bgPr>
     </p:bg>
     <p:spTree>
@@ -2354,6 +2122,13 @@
             <a:prstDash val="solid"/>
           </a:ln>
         </p:spPr>
+        <p:txBody>
+          <a:bodyPr/>
+          <a:lstStyle/>
+          <a:p>
+            <a:endParaRPr lang="en-US"/>
+          </a:p>
+        </p:txBody>
       </p:sp>
       <p:sp>
         <p:nvSpPr>
@@ -2376,7 +2151,7 @@
           <a:bodyPr wrap="square" lIns="0" tIns="0" rIns="0" bIns="0" rtlCol="0" anchor="ctr"/>
           <a:lstStyle/>
           <a:p>
-            <a:pPr indent="0" marL="0">
+            <a:pPr marL="0" indent="0">
               <a:buNone/>
             </a:pPr>
             <a:r>
@@ -2415,7 +2190,7 @@
           <a:bodyPr wrap="square" lIns="0" tIns="0" rIns="0" bIns="0" rtlCol="0" anchor="ctr"/>
           <a:lstStyle/>
           <a:p>
-            <a:pPr indent="0" marL="0">
+            <a:pPr marL="0" indent="0">
               <a:buNone/>
             </a:pPr>
             <a:r>
@@ -2459,6 +2234,13 @@
             <a:prstDash val="solid"/>
           </a:ln>
         </p:spPr>
+        <p:txBody>
+          <a:bodyPr/>
+          <a:lstStyle/>
+          <a:p>
+            <a:endParaRPr lang="en-US"/>
+          </a:p>
+        </p:txBody>
       </p:sp>
       <p:sp>
         <p:nvSpPr>
@@ -2486,6 +2268,13 @@
             <a:prstDash val="solid"/>
           </a:ln>
         </p:spPr>
+        <p:txBody>
+          <a:bodyPr/>
+          <a:lstStyle/>
+          <a:p>
+            <a:endParaRPr lang="en-US"/>
+          </a:p>
+        </p:txBody>
       </p:sp>
       <p:sp>
         <p:nvSpPr>
@@ -2508,7 +2297,7 @@
           <a:bodyPr wrap="square" lIns="0" tIns="0" rIns="0" bIns="0" rtlCol="0" anchor="ctr"/>
           <a:lstStyle/>
           <a:p>
-            <a:pPr indent="0" marL="0">
+            <a:pPr marL="0" indent="0">
               <a:buNone/>
             </a:pPr>
             <a:r>
@@ -2632,7 +2421,7 @@
           <a:bodyPr wrap="square" lIns="0" tIns="0" rIns="0" bIns="0" rtlCol="0" anchor="ctr"/>
           <a:lstStyle/>
           <a:p>
-            <a:pPr indent="0" marL="0">
+            <a:pPr marL="0" indent="0">
               <a:buNone/>
             </a:pPr>
             <a:r>
@@ -2751,6 +2540,7 @@
         <a:solidFill>
           <a:srgbClr val="FFFFFF"/>
         </a:solidFill>
+        <a:effectLst/>
       </p:bgPr>
     </p:bg>
     <p:spTree>
@@ -2791,6 +2581,13 @@
             <a:prstDash val="solid"/>
           </a:ln>
         </p:spPr>
+        <p:txBody>
+          <a:bodyPr/>
+          <a:lstStyle/>
+          <a:p>
+            <a:endParaRPr lang="en-US"/>
+          </a:p>
+        </p:txBody>
       </p:sp>
       <p:sp>
         <p:nvSpPr>
@@ -2813,7 +2610,7 @@
           <a:bodyPr wrap="square" lIns="0" tIns="0" rIns="0" bIns="0" rtlCol="0" anchor="ctr"/>
           <a:lstStyle/>
           <a:p>
-            <a:pPr indent="0" marL="0">
+            <a:pPr marL="0" indent="0">
               <a:buNone/>
             </a:pPr>
             <a:r>
@@ -2852,7 +2649,7 @@
           <a:bodyPr wrap="square" lIns="0" tIns="0" rIns="0" bIns="0" rtlCol="0" anchor="ctr"/>
           <a:lstStyle/>
           <a:p>
-            <a:pPr indent="0" marL="0">
+            <a:pPr marL="0" indent="0">
               <a:buNone/>
             </a:pPr>
             <a:r>
@@ -2872,7 +2669,7 @@
       </p:sp>
       <p:graphicFrame>
         <p:nvGraphicFramePr>
-          <p:cNvPr id="4" name="Table 0"/>
+          <p:cNvPr id="5" name="Table 0"/>
           <p:cNvGraphicFramePr>
             <a:graphicFrameLocks noGrp="1"/>
           </p:cNvGraphicFramePr>
@@ -2886,18 +2683,48 @@
         </p:nvGraphicFramePr>
         <p:xfrm>
           <a:off x="457200" y="1188720"/>
-          <a:ext cx="8229600" cy="914400"/>
+          <a:ext cx="8229600" cy="2438400"/>
         </p:xfrm>
         <a:graphic>
           <a:graphicData uri="http://schemas.openxmlformats.org/drawingml/2006/table">
             <a:tbl>
               <a:tblPr/>
               <a:tblGrid>
-                <a:gridCol w="1737360"/>
-                <a:gridCol w="1188720"/>
-                <a:gridCol w="1188720"/>
-                <a:gridCol w="1645920"/>
-                <a:gridCol w="2468880"/>
+                <a:gridCol w="1737360">
+                  <a:extLst>
+                    <a:ext uri="{9D8B030D-6E8A-4147-A177-3AD203B41FA5}">
+                      <a16:colId xmlns:a16="http://schemas.microsoft.com/office/drawing/2014/main" val="20000"/>
+                    </a:ext>
+                  </a:extLst>
+                </a:gridCol>
+                <a:gridCol w="1188720">
+                  <a:extLst>
+                    <a:ext uri="{9D8B030D-6E8A-4147-A177-3AD203B41FA5}">
+                      <a16:colId xmlns:a16="http://schemas.microsoft.com/office/drawing/2014/main" val="20001"/>
+                    </a:ext>
+                  </a:extLst>
+                </a:gridCol>
+                <a:gridCol w="1188720">
+                  <a:extLst>
+                    <a:ext uri="{9D8B030D-6E8A-4147-A177-3AD203B41FA5}">
+                      <a16:colId xmlns:a16="http://schemas.microsoft.com/office/drawing/2014/main" val="20002"/>
+                    </a:ext>
+                  </a:extLst>
+                </a:gridCol>
+                <a:gridCol w="1645920">
+                  <a:extLst>
+                    <a:ext uri="{9D8B030D-6E8A-4147-A177-3AD203B41FA5}">
+                      <a16:colId xmlns:a16="http://schemas.microsoft.com/office/drawing/2014/main" val="20003"/>
+                    </a:ext>
+                  </a:extLst>
+                </a:gridCol>
+                <a:gridCol w="2468880">
+                  <a:extLst>
+                    <a:ext uri="{9D8B030D-6E8A-4147-A177-3AD203B41FA5}">
+                      <a16:colId xmlns:a16="http://schemas.microsoft.com/office/drawing/2014/main" val="20004"/>
+                    </a:ext>
+                  </a:extLst>
+                </a:gridCol>
               </a:tblGrid>
               <a:tr h="384048">
                 <a:tc>
@@ -2905,7 +2732,7 @@
                     <a:bodyPr/>
                     <a:lstStyle/>
                     <a:p>
-                      <a:pPr algn="ctr" indent="0" marL="0">
+                      <a:pPr marL="0" indent="0" algn="ctr">
                         <a:buNone/>
                       </a:pPr>
                       <a:r>
@@ -2926,7 +2753,7 @@
                       </a:endParaRPr>
                     </a:p>
                   </a:txBody>
-                  <a:tcPr marL="91440" marR="91440" marT="45720" marB="45720" anchor="ctr">
+                  <a:tcPr anchor="ctr">
                     <a:lnL w="6350" cap="flat" cmpd="sng" algn="ctr">
                       <a:solidFill>
                         <a:srgbClr val="DDDFEA"/>
@@ -2973,7 +2800,7 @@
                     <a:bodyPr/>
                     <a:lstStyle/>
                     <a:p>
-                      <a:pPr algn="ctr" indent="0" marL="0">
+                      <a:pPr marL="0" indent="0" algn="ctr">
                         <a:buNone/>
                       </a:pPr>
                       <a:r>
@@ -2994,7 +2821,7 @@
                       </a:endParaRPr>
                     </a:p>
                   </a:txBody>
-                  <a:tcPr marL="91440" marR="91440" marT="45720" marB="45720" anchor="ctr">
+                  <a:tcPr anchor="ctr">
                     <a:lnL w="6350" cap="flat" cmpd="sng" algn="ctr">
                       <a:solidFill>
                         <a:srgbClr val="DDDFEA"/>
@@ -3041,7 +2868,7 @@
                     <a:bodyPr/>
                     <a:lstStyle/>
                     <a:p>
-                      <a:pPr algn="ctr" indent="0" marL="0">
+                      <a:pPr marL="0" indent="0" algn="ctr">
                         <a:buNone/>
                       </a:pPr>
                       <a:r>
@@ -3062,7 +2889,7 @@
                       </a:endParaRPr>
                     </a:p>
                   </a:txBody>
-                  <a:tcPr marL="91440" marR="91440" marT="45720" marB="45720" anchor="ctr">
+                  <a:tcPr anchor="ctr">
                     <a:lnL w="6350" cap="flat" cmpd="sng" algn="ctr">
                       <a:solidFill>
                         <a:srgbClr val="DDDFEA"/>
@@ -3109,7 +2936,7 @@
                     <a:bodyPr/>
                     <a:lstStyle/>
                     <a:p>
-                      <a:pPr algn="ctr" indent="0" marL="0">
+                      <a:pPr marL="0" indent="0" algn="ctr">
                         <a:buNone/>
                       </a:pPr>
                       <a:r>
@@ -3130,7 +2957,7 @@
                       </a:endParaRPr>
                     </a:p>
                   </a:txBody>
-                  <a:tcPr marL="91440" marR="91440" marT="45720" marB="45720" anchor="ctr">
+                  <a:tcPr anchor="ctr">
                     <a:lnL w="6350" cap="flat" cmpd="sng" algn="ctr">
                       <a:solidFill>
                         <a:srgbClr val="DDDFEA"/>
@@ -3177,7 +3004,7 @@
                     <a:bodyPr/>
                     <a:lstStyle/>
                     <a:p>
-                      <a:pPr algn="ctr" indent="0" marL="0">
+                      <a:pPr marL="0" indent="0" algn="ctr">
                         <a:buNone/>
                       </a:pPr>
                       <a:r>
@@ -3198,7 +3025,7 @@
                       </a:endParaRPr>
                     </a:p>
                   </a:txBody>
-                  <a:tcPr marL="91440" marR="91440" marT="45720" marB="45720" anchor="ctr">
+                  <a:tcPr anchor="ctr">
                     <a:lnL w="6350" cap="flat" cmpd="sng" algn="ctr">
                       <a:solidFill>
                         <a:srgbClr val="DDDFEA"/>
@@ -3240,6 +3067,11 @@
                     </a:solidFill>
                   </a:tcPr>
                 </a:tc>
+                <a:extLst>
+                  <a:ext uri="{0D108BD9-81ED-4DB2-BD59-A6C34878D82A}">
+                    <a16:rowId xmlns:a16="http://schemas.microsoft.com/office/drawing/2014/main" val="10000"/>
+                  </a:ext>
+                </a:extLst>
               </a:tr>
               <a:tr h="384048">
                 <a:tc>
@@ -3247,7 +3079,7 @@
                     <a:bodyPr/>
                     <a:lstStyle/>
                     <a:p>
-                      <a:pPr indent="0" marL="0">
+                      <a:pPr marL="0" indent="0">
                         <a:buNone/>
                       </a:pPr>
                       <a:r>
@@ -3268,7 +3100,7 @@
                       </a:endParaRPr>
                     </a:p>
                   </a:txBody>
-                  <a:tcPr marL="91440" marR="91440" marT="45720" marB="45720" anchor="ctr">
+                  <a:tcPr anchor="ctr">
                     <a:lnL w="6350" cap="flat" cmpd="sng" algn="ctr">
                       <a:solidFill>
                         <a:srgbClr val="DDDFEA"/>
@@ -3312,7 +3144,7 @@
                     <a:bodyPr/>
                     <a:lstStyle/>
                     <a:p>
-                      <a:pPr algn="ctr" indent="0" marL="0">
+                      <a:pPr marL="0" indent="0" algn="ctr">
                         <a:buNone/>
                       </a:pPr>
                       <a:r>
@@ -3333,7 +3165,7 @@
                       </a:endParaRPr>
                     </a:p>
                   </a:txBody>
-                  <a:tcPr marL="91440" marR="91440" marT="45720" marB="45720" anchor="ctr">
+                  <a:tcPr anchor="ctr">
                     <a:lnL w="6350" cap="flat" cmpd="sng" algn="ctr">
                       <a:solidFill>
                         <a:srgbClr val="DDDFEA"/>
@@ -3377,7 +3209,7 @@
                     <a:bodyPr/>
                     <a:lstStyle/>
                     <a:p>
-                      <a:pPr algn="ctr" indent="0" marL="0">
+                      <a:pPr marL="0" indent="0" algn="ctr">
                         <a:buNone/>
                       </a:pPr>
                       <a:r>
@@ -3398,7 +3230,7 @@
                       </a:endParaRPr>
                     </a:p>
                   </a:txBody>
-                  <a:tcPr marL="91440" marR="91440" marT="45720" marB="45720" anchor="ctr">
+                  <a:tcPr anchor="ctr">
                     <a:lnL w="6350" cap="flat" cmpd="sng" algn="ctr">
                       <a:solidFill>
                         <a:srgbClr val="DDDFEA"/>
@@ -3442,7 +3274,7 @@
                     <a:bodyPr/>
                     <a:lstStyle/>
                     <a:p>
-                      <a:pPr algn="ctr" indent="0" marL="0">
+                      <a:pPr marL="0" indent="0" algn="ctr">
                         <a:buNone/>
                       </a:pPr>
                       <a:r>
@@ -3463,7 +3295,7 @@
                       </a:endParaRPr>
                     </a:p>
                   </a:txBody>
-                  <a:tcPr marL="91440" marR="91440" marT="45720" marB="45720" anchor="ctr">
+                  <a:tcPr anchor="ctr">
                     <a:lnL w="6350" cap="flat" cmpd="sng" algn="ctr">
                       <a:solidFill>
                         <a:srgbClr val="DDDFEA"/>
@@ -3507,7 +3339,7 @@
                     <a:bodyPr/>
                     <a:lstStyle/>
                     <a:p>
-                      <a:pPr indent="0" marL="0">
+                      <a:pPr marL="0" indent="0">
                         <a:buNone/>
                       </a:pPr>
                       <a:r>
@@ -3528,7 +3360,7 @@
                       </a:endParaRPr>
                     </a:p>
                   </a:txBody>
-                  <a:tcPr marL="91440" marR="91440" marT="45720" marB="45720" anchor="ctr">
+                  <a:tcPr anchor="ctr">
                     <a:lnL w="6350" cap="flat" cmpd="sng" algn="ctr">
                       <a:solidFill>
                         <a:srgbClr val="DDDFEA"/>
@@ -3567,6 +3399,11 @@
                     </a:lnB>
                   </a:tcPr>
                 </a:tc>
+                <a:extLst>
+                  <a:ext uri="{0D108BD9-81ED-4DB2-BD59-A6C34878D82A}">
+                    <a16:rowId xmlns:a16="http://schemas.microsoft.com/office/drawing/2014/main" val="10001"/>
+                  </a:ext>
+                </a:extLst>
               </a:tr>
               <a:tr h="384048">
                 <a:tc>
@@ -3574,7 +3411,7 @@
                     <a:bodyPr/>
                     <a:lstStyle/>
                     <a:p>
-                      <a:pPr indent="0" marL="0">
+                      <a:pPr marL="0" indent="0">
                         <a:buNone/>
                       </a:pPr>
                       <a:r>
@@ -3595,7 +3432,7 @@
                       </a:endParaRPr>
                     </a:p>
                   </a:txBody>
-                  <a:tcPr marL="91440" marR="91440" marT="45720" marB="45720" anchor="ctr">
+                  <a:tcPr anchor="ctr">
                     <a:lnL w="6350" cap="flat" cmpd="sng" algn="ctr">
                       <a:solidFill>
                         <a:srgbClr val="DDDFEA"/>
@@ -3639,7 +3476,7 @@
                     <a:bodyPr/>
                     <a:lstStyle/>
                     <a:p>
-                      <a:pPr algn="ctr" indent="0" marL="0">
+                      <a:pPr marL="0" indent="0" algn="ctr">
                         <a:buNone/>
                       </a:pPr>
                       <a:r>
@@ -3660,7 +3497,7 @@
                       </a:endParaRPr>
                     </a:p>
                   </a:txBody>
-                  <a:tcPr marL="91440" marR="91440" marT="45720" marB="45720" anchor="ctr">
+                  <a:tcPr anchor="ctr">
                     <a:lnL w="6350" cap="flat" cmpd="sng" algn="ctr">
                       <a:solidFill>
                         <a:srgbClr val="DDDFEA"/>
@@ -3704,7 +3541,7 @@
                     <a:bodyPr/>
                     <a:lstStyle/>
                     <a:p>
-                      <a:pPr algn="ctr" indent="0" marL="0">
+                      <a:pPr marL="0" indent="0" algn="ctr">
                         <a:buNone/>
                       </a:pPr>
                       <a:r>
@@ -3725,7 +3562,7 @@
                       </a:endParaRPr>
                     </a:p>
                   </a:txBody>
-                  <a:tcPr marL="91440" marR="91440" marT="45720" marB="45720" anchor="ctr">
+                  <a:tcPr anchor="ctr">
                     <a:lnL w="6350" cap="flat" cmpd="sng" algn="ctr">
                       <a:solidFill>
                         <a:srgbClr val="DDDFEA"/>
@@ -3769,7 +3606,7 @@
                     <a:bodyPr/>
                     <a:lstStyle/>
                     <a:p>
-                      <a:pPr algn="ctr" indent="0" marL="0">
+                      <a:pPr marL="0" indent="0" algn="ctr">
                         <a:buNone/>
                       </a:pPr>
                       <a:r>
@@ -3790,7 +3627,7 @@
                       </a:endParaRPr>
                     </a:p>
                   </a:txBody>
-                  <a:tcPr marL="91440" marR="91440" marT="45720" marB="45720" anchor="ctr">
+                  <a:tcPr anchor="ctr">
                     <a:lnL w="6350" cap="flat" cmpd="sng" algn="ctr">
                       <a:solidFill>
                         <a:srgbClr val="DDDFEA"/>
@@ -3834,7 +3671,7 @@
                     <a:bodyPr/>
                     <a:lstStyle/>
                     <a:p>
-                      <a:pPr indent="0" marL="0">
+                      <a:pPr marL="0" indent="0">
                         <a:buNone/>
                       </a:pPr>
                       <a:r>
@@ -3855,7 +3692,7 @@
                       </a:endParaRPr>
                     </a:p>
                   </a:txBody>
-                  <a:tcPr marL="91440" marR="91440" marT="45720" marB="45720" anchor="ctr">
+                  <a:tcPr anchor="ctr">
                     <a:lnL w="6350" cap="flat" cmpd="sng" algn="ctr">
                       <a:solidFill>
                         <a:srgbClr val="DDDFEA"/>
@@ -3894,6 +3731,11 @@
                     </a:lnB>
                   </a:tcPr>
                 </a:tc>
+                <a:extLst>
+                  <a:ext uri="{0D108BD9-81ED-4DB2-BD59-A6C34878D82A}">
+                    <a16:rowId xmlns:a16="http://schemas.microsoft.com/office/drawing/2014/main" val="10002"/>
+                  </a:ext>
+                </a:extLst>
               </a:tr>
               <a:tr h="384048">
                 <a:tc>
@@ -3901,7 +3743,7 @@
                     <a:bodyPr/>
                     <a:lstStyle/>
                     <a:p>
-                      <a:pPr indent="0" marL="0">
+                      <a:pPr marL="0" indent="0">
                         <a:buNone/>
                       </a:pPr>
                       <a:r>
@@ -3922,7 +3764,7 @@
                       </a:endParaRPr>
                     </a:p>
                   </a:txBody>
-                  <a:tcPr marL="91440" marR="91440" marT="45720" marB="45720" anchor="ctr">
+                  <a:tcPr anchor="ctr">
                     <a:lnL w="6350" cap="flat" cmpd="sng" algn="ctr">
                       <a:solidFill>
                         <a:srgbClr val="DDDFEA"/>
@@ -3966,7 +3808,7 @@
                     <a:bodyPr/>
                     <a:lstStyle/>
                     <a:p>
-                      <a:pPr algn="ctr" indent="0" marL="0">
+                      <a:pPr marL="0" indent="0" algn="ctr">
                         <a:buNone/>
                       </a:pPr>
                       <a:r>
@@ -3987,7 +3829,7 @@
                       </a:endParaRPr>
                     </a:p>
                   </a:txBody>
-                  <a:tcPr marL="91440" marR="91440" marT="45720" marB="45720" anchor="ctr">
+                  <a:tcPr anchor="ctr">
                     <a:lnL w="6350" cap="flat" cmpd="sng" algn="ctr">
                       <a:solidFill>
                         <a:srgbClr val="DDDFEA"/>
@@ -4031,7 +3873,7 @@
                     <a:bodyPr/>
                     <a:lstStyle/>
                     <a:p>
-                      <a:pPr algn="ctr" indent="0" marL="0">
+                      <a:pPr marL="0" indent="0" algn="ctr">
                         <a:buNone/>
                       </a:pPr>
                       <a:r>
@@ -4052,7 +3894,7 @@
                       </a:endParaRPr>
                     </a:p>
                   </a:txBody>
-                  <a:tcPr marL="91440" marR="91440" marT="45720" marB="45720" anchor="ctr">
+                  <a:tcPr anchor="ctr">
                     <a:lnL w="6350" cap="flat" cmpd="sng" algn="ctr">
                       <a:solidFill>
                         <a:srgbClr val="DDDFEA"/>
@@ -4096,7 +3938,7 @@
                     <a:bodyPr/>
                     <a:lstStyle/>
                     <a:p>
-                      <a:pPr algn="ctr" indent="0" marL="0">
+                      <a:pPr marL="0" indent="0" algn="ctr">
                         <a:buNone/>
                       </a:pPr>
                       <a:r>
@@ -4117,7 +3959,7 @@
                       </a:endParaRPr>
                     </a:p>
                   </a:txBody>
-                  <a:tcPr marL="91440" marR="91440" marT="45720" marB="45720" anchor="ctr">
+                  <a:tcPr anchor="ctr">
                     <a:lnL w="6350" cap="flat" cmpd="sng" algn="ctr">
                       <a:solidFill>
                         <a:srgbClr val="DDDFEA"/>
@@ -4161,7 +4003,7 @@
                     <a:bodyPr/>
                     <a:lstStyle/>
                     <a:p>
-                      <a:pPr indent="0" marL="0">
+                      <a:pPr marL="0" indent="0">
                         <a:buNone/>
                       </a:pPr>
                       <a:r>
@@ -4182,7 +4024,7 @@
                       </a:endParaRPr>
                     </a:p>
                   </a:txBody>
-                  <a:tcPr marL="91440" marR="91440" marT="45720" marB="45720" anchor="ctr">
+                  <a:tcPr anchor="ctr">
                     <a:lnL w="6350" cap="flat" cmpd="sng" algn="ctr">
                       <a:solidFill>
                         <a:srgbClr val="DDDFEA"/>
@@ -4221,6 +4063,11 @@
                     </a:lnB>
                   </a:tcPr>
                 </a:tc>
+                <a:extLst>
+                  <a:ext uri="{0D108BD9-81ED-4DB2-BD59-A6C34878D82A}">
+                    <a16:rowId xmlns:a16="http://schemas.microsoft.com/office/drawing/2014/main" val="10003"/>
+                  </a:ext>
+                </a:extLst>
               </a:tr>
               <a:tr h="384048">
                 <a:tc>
@@ -4228,7 +4075,7 @@
                     <a:bodyPr/>
                     <a:lstStyle/>
                     <a:p>
-                      <a:pPr indent="0" marL="0">
+                      <a:pPr marL="0" indent="0">
                         <a:buNone/>
                       </a:pPr>
                       <a:r>
@@ -4249,7 +4096,7 @@
                       </a:endParaRPr>
                     </a:p>
                   </a:txBody>
-                  <a:tcPr marL="91440" marR="91440" marT="45720" marB="45720" anchor="ctr">
+                  <a:tcPr anchor="ctr">
                     <a:lnL w="6350" cap="flat" cmpd="sng" algn="ctr">
                       <a:solidFill>
                         <a:srgbClr val="DDDFEA"/>
@@ -4293,7 +4140,7 @@
                     <a:bodyPr/>
                     <a:lstStyle/>
                     <a:p>
-                      <a:pPr algn="ctr" indent="0" marL="0">
+                      <a:pPr marL="0" indent="0" algn="ctr">
                         <a:buNone/>
                       </a:pPr>
                       <a:r>
@@ -4314,7 +4161,7 @@
                       </a:endParaRPr>
                     </a:p>
                   </a:txBody>
-                  <a:tcPr marL="91440" marR="91440" marT="45720" marB="45720" anchor="ctr">
+                  <a:tcPr anchor="ctr">
                     <a:lnL w="6350" cap="flat" cmpd="sng" algn="ctr">
                       <a:solidFill>
                         <a:srgbClr val="DDDFEA"/>
@@ -4358,7 +4205,7 @@
                     <a:bodyPr/>
                     <a:lstStyle/>
                     <a:p>
-                      <a:pPr algn="ctr" indent="0" marL="0">
+                      <a:pPr marL="0" indent="0" algn="ctr">
                         <a:buNone/>
                       </a:pPr>
                       <a:r>
@@ -4379,7 +4226,7 @@
                       </a:endParaRPr>
                     </a:p>
                   </a:txBody>
-                  <a:tcPr marL="91440" marR="91440" marT="45720" marB="45720" anchor="ctr">
+                  <a:tcPr anchor="ctr">
                     <a:lnL w="6350" cap="flat" cmpd="sng" algn="ctr">
                       <a:solidFill>
                         <a:srgbClr val="DDDFEA"/>
@@ -4423,7 +4270,7 @@
                     <a:bodyPr/>
                     <a:lstStyle/>
                     <a:p>
-                      <a:pPr algn="ctr" indent="0" marL="0">
+                      <a:pPr marL="0" indent="0" algn="ctr">
                         <a:buNone/>
                       </a:pPr>
                       <a:r>
@@ -4444,7 +4291,7 @@
                       </a:endParaRPr>
                     </a:p>
                   </a:txBody>
-                  <a:tcPr marL="91440" marR="91440" marT="45720" marB="45720" anchor="ctr">
+                  <a:tcPr anchor="ctr">
                     <a:lnL w="6350" cap="flat" cmpd="sng" algn="ctr">
                       <a:solidFill>
                         <a:srgbClr val="DDDFEA"/>
@@ -4488,7 +4335,7 @@
                     <a:bodyPr/>
                     <a:lstStyle/>
                     <a:p>
-                      <a:pPr indent="0" marL="0">
+                      <a:pPr marL="0" indent="0">
                         <a:buNone/>
                       </a:pPr>
                       <a:r>
@@ -4509,7 +4356,7 @@
                       </a:endParaRPr>
                     </a:p>
                   </a:txBody>
-                  <a:tcPr marL="91440" marR="91440" marT="45720" marB="45720" anchor="ctr">
+                  <a:tcPr anchor="ctr">
                     <a:lnL w="6350" cap="flat" cmpd="sng" algn="ctr">
                       <a:solidFill>
                         <a:srgbClr val="DDDFEA"/>
@@ -4548,6 +4395,11 @@
                     </a:lnB>
                   </a:tcPr>
                 </a:tc>
+                <a:extLst>
+                  <a:ext uri="{0D108BD9-81ED-4DB2-BD59-A6C34878D82A}">
+                    <a16:rowId xmlns:a16="http://schemas.microsoft.com/office/drawing/2014/main" val="10004"/>
+                  </a:ext>
+                </a:extLst>
               </a:tr>
             </a:tbl>
           </a:graphicData>
@@ -4579,6 +4431,13 @@
             <a:prstDash val="solid"/>
           </a:ln>
         </p:spPr>
+        <p:txBody>
+          <a:bodyPr/>
+          <a:lstStyle/>
+          <a:p>
+            <a:endParaRPr lang="en-US"/>
+          </a:p>
+        </p:txBody>
       </p:sp>
       <p:sp>
         <p:nvSpPr>
@@ -4601,7 +4460,7 @@
           <a:bodyPr wrap="square" lIns="0" tIns="0" rIns="0" bIns="0" rtlCol="0" anchor="ctr"/>
           <a:lstStyle/>
           <a:p>
-            <a:pPr indent="0" marL="0">
+            <a:pPr marL="0" indent="0">
               <a:buNone/>
             </a:pPr>
             <a:r>
@@ -4615,9 +4474,6 @@
               </a:rPr>
               <a:t>Trends we are riding: </a:t>
             </a:r>
-            <a:pPr indent="0" marL="0">
-              <a:buNone/>
-            </a:pPr>
             <a:r>
               <a:rPr lang="en-US" sz="1250" dirty="0">
                 <a:solidFill>
@@ -4630,9 +4486,6 @@
               <a:t>growing interest in mental-wellbeing and self-tracking, preference for simple privacy-respecting tools, and data-driven “quantified self” insights.
 </a:t>
             </a:r>
-            <a:pPr indent="0" marL="0">
-              <a:buNone/>
-            </a:pPr>
             <a:r>
               <a:rPr lang="en-US" sz="1250" b="1" dirty="0">
                 <a:solidFill>
@@ -4644,9 +4497,6 @@
               </a:rPr>
               <a:t>Monetisation potential: </a:t>
             </a:r>
-            <a:pPr indent="0" marL="0">
-              <a:buNone/>
-            </a:pPr>
             <a:r>
               <a:rPr lang="en-US" sz="1250" dirty="0">
                 <a:solidFill>
@@ -4678,6 +4528,7 @@
         <a:solidFill>
           <a:srgbClr val="FFFFFF"/>
         </a:solidFill>
+        <a:effectLst/>
       </p:bgPr>
     </p:bg>
     <p:spTree>
@@ -4718,6 +4569,13 @@
             <a:prstDash val="solid"/>
           </a:ln>
         </p:spPr>
+        <p:txBody>
+          <a:bodyPr/>
+          <a:lstStyle/>
+          <a:p>
+            <a:endParaRPr lang="en-US"/>
+          </a:p>
+        </p:txBody>
       </p:sp>
       <p:sp>
         <p:nvSpPr>
@@ -4740,7 +4598,7 @@
           <a:bodyPr wrap="square" lIns="0" tIns="0" rIns="0" bIns="0" rtlCol="0" anchor="ctr"/>
           <a:lstStyle/>
           <a:p>
-            <a:pPr indent="0" marL="0">
+            <a:pPr marL="0" indent="0">
               <a:buNone/>
             </a:pPr>
             <a:r>
@@ -4779,7 +4637,7 @@
           <a:bodyPr wrap="square" lIns="0" tIns="0" rIns="0" bIns="0" rtlCol="0" anchor="ctr"/>
           <a:lstStyle/>
           <a:p>
-            <a:pPr indent="0" marL="0">
+            <a:pPr marL="0" indent="0">
               <a:buNone/>
             </a:pPr>
             <a:r>
@@ -4823,6 +4681,13 @@
             <a:prstDash val="solid"/>
           </a:ln>
         </p:spPr>
+        <p:txBody>
+          <a:bodyPr/>
+          <a:lstStyle/>
+          <a:p>
+            <a:endParaRPr lang="en-US"/>
+          </a:p>
+        </p:txBody>
       </p:sp>
       <p:sp>
         <p:nvSpPr>
@@ -4845,7 +4710,7 @@
           <a:bodyPr wrap="square" lIns="0" tIns="0" rIns="0" bIns="0" rtlCol="0" anchor="ctr"/>
           <a:lstStyle/>
           <a:p>
-            <a:pPr indent="0" marL="0">
+            <a:pPr marL="0" indent="0">
               <a:buNone/>
             </a:pPr>
             <a:r>
@@ -4884,7 +4749,7 @@
           <a:bodyPr wrap="square" lIns="0" tIns="0" rIns="0" bIns="0" rtlCol="0" anchor="t"/>
           <a:lstStyle/>
           <a:p>
-            <a:pPr indent="0" marL="0">
+            <a:pPr marL="0" indent="0">
               <a:buNone/>
             </a:pPr>
             <a:r>
@@ -4928,6 +4793,13 @@
             <a:prstDash val="solid"/>
           </a:ln>
         </p:spPr>
+        <p:txBody>
+          <a:bodyPr/>
+          <a:lstStyle/>
+          <a:p>
+            <a:endParaRPr lang="en-US"/>
+          </a:p>
+        </p:txBody>
       </p:sp>
       <p:sp>
         <p:nvSpPr>
@@ -4950,7 +4822,7 @@
           <a:bodyPr wrap="square" lIns="0" tIns="0" rIns="0" bIns="0" rtlCol="0" anchor="ctr"/>
           <a:lstStyle/>
           <a:p>
-            <a:pPr indent="0" marL="0">
+            <a:pPr marL="0" indent="0">
               <a:buNone/>
             </a:pPr>
             <a:r>
@@ -4989,7 +4861,7 @@
           <a:bodyPr wrap="square" lIns="0" tIns="0" rIns="0" bIns="0" rtlCol="0" anchor="t"/>
           <a:lstStyle/>
           <a:p>
-            <a:pPr indent="0" marL="0">
+            <a:pPr marL="0" indent="0">
               <a:buNone/>
             </a:pPr>
             <a:r>
@@ -5033,6 +4905,13 @@
             <a:prstDash val="solid"/>
           </a:ln>
         </p:spPr>
+        <p:txBody>
+          <a:bodyPr/>
+          <a:lstStyle/>
+          <a:p>
+            <a:endParaRPr lang="en-US"/>
+          </a:p>
+        </p:txBody>
       </p:sp>
       <p:sp>
         <p:nvSpPr>
@@ -5055,7 +4934,7 @@
           <a:bodyPr wrap="square" lIns="0" tIns="0" rIns="0" bIns="0" rtlCol="0" anchor="ctr"/>
           <a:lstStyle/>
           <a:p>
-            <a:pPr indent="0" marL="0">
+            <a:pPr marL="0" indent="0">
               <a:buNone/>
             </a:pPr>
             <a:r>
@@ -5094,7 +4973,7 @@
           <a:bodyPr wrap="square" lIns="0" tIns="0" rIns="0" bIns="0" rtlCol="0" anchor="t"/>
           <a:lstStyle/>
           <a:p>
-            <a:pPr indent="0" marL="0">
+            <a:pPr marL="0" indent="0">
               <a:buNone/>
             </a:pPr>
             <a:r>
@@ -5138,6 +5017,13 @@
             <a:prstDash val="solid"/>
           </a:ln>
         </p:spPr>
+        <p:txBody>
+          <a:bodyPr/>
+          <a:lstStyle/>
+          <a:p>
+            <a:endParaRPr lang="en-US"/>
+          </a:p>
+        </p:txBody>
       </p:sp>
       <p:sp>
         <p:nvSpPr>
@@ -5160,7 +5046,7 @@
           <a:bodyPr wrap="square" lIns="0" tIns="0" rIns="0" bIns="0" rtlCol="0" anchor="ctr"/>
           <a:lstStyle/>
           <a:p>
-            <a:pPr indent="0" marL="0">
+            <a:pPr marL="0" indent="0">
               <a:buNone/>
             </a:pPr>
             <a:r>
@@ -5199,7 +5085,7 @@
           <a:bodyPr wrap="square" lIns="0" tIns="0" rIns="0" bIns="0" rtlCol="0" anchor="t"/>
           <a:lstStyle/>
           <a:p>
-            <a:pPr indent="0" marL="0">
+            <a:pPr marL="0" indent="0">
               <a:buNone/>
             </a:pPr>
             <a:r>
@@ -5243,6 +5129,13 @@
             <a:prstDash val="solid"/>
           </a:ln>
         </p:spPr>
+        <p:txBody>
+          <a:bodyPr/>
+          <a:lstStyle/>
+          <a:p>
+            <a:endParaRPr lang="en-US"/>
+          </a:p>
+        </p:txBody>
       </p:sp>
       <p:sp>
         <p:nvSpPr>
@@ -5265,7 +5158,7 @@
           <a:bodyPr wrap="square" lIns="0" tIns="0" rIns="0" bIns="0" rtlCol="0" anchor="ctr"/>
           <a:lstStyle/>
           <a:p>
-            <a:pPr indent="0" marL="0">
+            <a:pPr marL="0" indent="0">
               <a:buNone/>
             </a:pPr>
             <a:r>
@@ -5304,7 +5197,7 @@
           <a:bodyPr wrap="square" lIns="0" tIns="0" rIns="0" bIns="0" rtlCol="0" anchor="t"/>
           <a:lstStyle/>
           <a:p>
-            <a:pPr indent="0" marL="0">
+            <a:pPr marL="0" indent="0">
               <a:buNone/>
             </a:pPr>
             <a:r>
@@ -5348,6 +5241,13 @@
             <a:prstDash val="solid"/>
           </a:ln>
         </p:spPr>
+        <p:txBody>
+          <a:bodyPr/>
+          <a:lstStyle/>
+          <a:p>
+            <a:endParaRPr lang="en-US"/>
+          </a:p>
+        </p:txBody>
       </p:sp>
       <p:sp>
         <p:nvSpPr>
@@ -5370,7 +5270,7 @@
           <a:bodyPr wrap="square" lIns="0" tIns="0" rIns="0" bIns="0" rtlCol="0" anchor="ctr"/>
           <a:lstStyle/>
           <a:p>
-            <a:pPr indent="0" marL="0">
+            <a:pPr marL="0" indent="0">
               <a:buNone/>
             </a:pPr>
             <a:r>
@@ -5409,7 +5309,7 @@
           <a:bodyPr wrap="square" lIns="0" tIns="0" rIns="0" bIns="0" rtlCol="0" anchor="t"/>
           <a:lstStyle/>
           <a:p>
-            <a:pPr indent="0" marL="0">
+            <a:pPr marL="0" indent="0">
               <a:buNone/>
             </a:pPr>
             <a:r>
@@ -5443,6 +5343,7 @@
         <a:solidFill>
           <a:srgbClr val="FFFFFF"/>
         </a:solidFill>
+        <a:effectLst/>
       </p:bgPr>
     </p:bg>
     <p:spTree>
@@ -5483,6 +5384,13 @@
             <a:prstDash val="solid"/>
           </a:ln>
         </p:spPr>
+        <p:txBody>
+          <a:bodyPr/>
+          <a:lstStyle/>
+          <a:p>
+            <a:endParaRPr lang="en-US"/>
+          </a:p>
+        </p:txBody>
       </p:sp>
       <p:sp>
         <p:nvSpPr>
@@ -5505,7 +5413,7 @@
           <a:bodyPr wrap="square" lIns="0" tIns="0" rIns="0" bIns="0" rtlCol="0" anchor="ctr"/>
           <a:lstStyle/>
           <a:p>
-            <a:pPr indent="0" marL="0">
+            <a:pPr marL="0" indent="0">
               <a:buNone/>
             </a:pPr>
             <a:r>
@@ -5544,7 +5452,7 @@
           <a:bodyPr wrap="square" lIns="0" tIns="0" rIns="0" bIns="0" rtlCol="0" anchor="ctr"/>
           <a:lstStyle/>
           <a:p>
-            <a:pPr indent="0" marL="0">
+            <a:pPr marL="0" indent="0">
               <a:buNone/>
             </a:pPr>
             <a:r>
@@ -5588,6 +5496,13 @@
             <a:prstDash val="solid"/>
           </a:ln>
         </p:spPr>
+        <p:txBody>
+          <a:bodyPr/>
+          <a:lstStyle/>
+          <a:p>
+            <a:endParaRPr lang="en-US"/>
+          </a:p>
+        </p:txBody>
       </p:sp>
       <p:sp>
         <p:nvSpPr>
@@ -5610,7 +5525,7 @@
           <a:bodyPr wrap="square" lIns="50800" tIns="50800" rIns="50800" bIns="50800" rtlCol="0" anchor="ctr"/>
           <a:lstStyle/>
           <a:p>
-            <a:pPr algn="ctr" indent="0" marL="0">
+            <a:pPr marL="0" indent="0" algn="ctr">
               <a:buNone/>
             </a:pPr>
             <a:r>
@@ -5627,7 +5542,7 @@
             <a:endParaRPr lang="en-US" sz="1400" dirty="0"/>
           </a:p>
           <a:p>
-            <a:pPr algn="ctr" indent="0" marL="0">
+            <a:pPr marL="0" indent="0" algn="ctr">
               <a:buNone/>
             </a:pPr>
             <a:r>
@@ -5644,7 +5559,7 @@
             <a:endParaRPr lang="en-US" sz="1400" dirty="0"/>
           </a:p>
           <a:p>
-            <a:pPr algn="ctr" indent="0" marL="0">
+            <a:pPr marL="0" indent="0" algn="ctr">
               <a:buNone/>
             </a:pPr>
             <a:r>
@@ -5661,7 +5576,7 @@
             <a:endParaRPr lang="en-US" sz="1400" dirty="0"/>
           </a:p>
           <a:p>
-            <a:pPr algn="ctr" indent="0" marL="0">
+            <a:pPr marL="0" indent="0" algn="ctr">
               <a:buNone/>
             </a:pPr>
             <a:r>
@@ -5705,6 +5620,13 @@
             <a:prstDash val="solid"/>
           </a:ln>
         </p:spPr>
+        <p:txBody>
+          <a:bodyPr/>
+          <a:lstStyle/>
+          <a:p>
+            <a:endParaRPr lang="en-US"/>
+          </a:p>
+        </p:txBody>
       </p:sp>
       <p:sp>
         <p:nvSpPr>
@@ -5727,7 +5649,7 @@
           <a:bodyPr wrap="square" lIns="50800" tIns="50800" rIns="50800" bIns="50800" rtlCol="0" anchor="ctr"/>
           <a:lstStyle/>
           <a:p>
-            <a:pPr algn="ctr" indent="0" marL="0">
+            <a:pPr marL="0" indent="0" algn="ctr">
               <a:buNone/>
             </a:pPr>
             <a:r>
@@ -5744,7 +5666,7 @@
             <a:endParaRPr lang="en-US" sz="1400" dirty="0"/>
           </a:p>
           <a:p>
-            <a:pPr algn="ctr" indent="0" marL="0">
+            <a:pPr marL="0" indent="0" algn="ctr">
               <a:buNone/>
             </a:pPr>
             <a:r>
@@ -5761,7 +5683,7 @@
             <a:endParaRPr lang="en-US" sz="1400" dirty="0"/>
           </a:p>
           <a:p>
-            <a:pPr algn="ctr" indent="0" marL="0">
+            <a:pPr marL="0" indent="0" algn="ctr">
               <a:buNone/>
             </a:pPr>
             <a:r>
@@ -5778,7 +5700,7 @@
             <a:endParaRPr lang="en-US" sz="1400" dirty="0"/>
           </a:p>
           <a:p>
-            <a:pPr algn="ctr" indent="0" marL="0">
+            <a:pPr marL="0" indent="0" algn="ctr">
               <a:buNone/>
             </a:pPr>
             <a:r>
@@ -5822,6 +5744,13 @@
             <a:prstDash val="solid"/>
           </a:ln>
         </p:spPr>
+        <p:txBody>
+          <a:bodyPr/>
+          <a:lstStyle/>
+          <a:p>
+            <a:endParaRPr lang="en-US"/>
+          </a:p>
+        </p:txBody>
       </p:sp>
       <p:sp>
         <p:nvSpPr>
@@ -5844,7 +5773,7 @@
           <a:bodyPr wrap="square" lIns="50800" tIns="50800" rIns="50800" bIns="50800" rtlCol="0" anchor="ctr"/>
           <a:lstStyle/>
           <a:p>
-            <a:pPr algn="ctr" indent="0" marL="0">
+            <a:pPr marL="0" indent="0" algn="ctr">
               <a:buNone/>
             </a:pPr>
             <a:r>
@@ -5861,7 +5790,7 @@
             <a:endParaRPr lang="en-US" sz="1400" dirty="0"/>
           </a:p>
           <a:p>
-            <a:pPr algn="ctr" indent="0" marL="0">
+            <a:pPr marL="0" indent="0" algn="ctr">
               <a:buNone/>
             </a:pPr>
             <a:r>
@@ -5878,7 +5807,7 @@
             <a:endParaRPr lang="en-US" sz="1400" dirty="0"/>
           </a:p>
           <a:p>
-            <a:pPr algn="ctr" indent="0" marL="0">
+            <a:pPr marL="0" indent="0" algn="ctr">
               <a:buNone/>
             </a:pPr>
             <a:r>
@@ -5895,7 +5824,7 @@
             <a:endParaRPr lang="en-US" sz="1400" dirty="0"/>
           </a:p>
           <a:p>
-            <a:pPr algn="ctr" indent="0" marL="0">
+            <a:pPr marL="0" indent="0" algn="ctr">
               <a:buNone/>
             </a:pPr>
             <a:r>
@@ -5937,6 +5866,13 @@
             <a:tailEnd type="triangle"/>
           </a:ln>
         </p:spPr>
+        <p:txBody>
+          <a:bodyPr/>
+          <a:lstStyle/>
+          <a:p>
+            <a:endParaRPr lang="en-US"/>
+          </a:p>
+        </p:txBody>
       </p:sp>
       <p:sp>
         <p:nvSpPr>
@@ -5959,7 +5895,7 @@
           <a:bodyPr wrap="square" lIns="0" tIns="0" rIns="0" bIns="0" rtlCol="0" anchor="b"/>
           <a:lstStyle/>
           <a:p>
-            <a:pPr algn="ctr" indent="0" marL="0">
+            <a:pPr marL="0" indent="0" algn="ctr">
               <a:buNone/>
             </a:pPr>
             <a:r>
@@ -5976,7 +5912,7 @@
             <a:endParaRPr lang="en-US" sz="1000" dirty="0"/>
           </a:p>
           <a:p>
-            <a:pPr algn="ctr" indent="0" marL="0">
+            <a:pPr marL="0" indent="0" algn="ctr">
               <a:buNone/>
             </a:pPr>
             <a:r>
@@ -6018,6 +5954,13 @@
             <a:tailEnd type="triangle"/>
           </a:ln>
         </p:spPr>
+        <p:txBody>
+          <a:bodyPr/>
+          <a:lstStyle/>
+          <a:p>
+            <a:endParaRPr lang="en-US"/>
+          </a:p>
+        </p:txBody>
       </p:sp>
       <p:sp>
         <p:nvSpPr>
@@ -6040,7 +5983,7 @@
           <a:bodyPr wrap="square" lIns="0" tIns="0" rIns="0" bIns="0" rtlCol="0" anchor="b"/>
           <a:lstStyle/>
           <a:p>
-            <a:pPr algn="ctr" indent="0" marL="0">
+            <a:pPr marL="0" indent="0" algn="ctr">
               <a:buNone/>
             </a:pPr>
             <a:r>
@@ -6057,7 +6000,7 @@
             <a:endParaRPr lang="en-US" sz="1000" dirty="0"/>
           </a:p>
           <a:p>
-            <a:pPr algn="ctr" indent="0" marL="0">
+            <a:pPr marL="0" indent="0" algn="ctr">
               <a:buNone/>
             </a:pPr>
             <a:r>
@@ -6101,6 +6044,13 @@
             <a:prstDash val="solid"/>
           </a:ln>
         </p:spPr>
+        <p:txBody>
+          <a:bodyPr/>
+          <a:lstStyle/>
+          <a:p>
+            <a:endParaRPr lang="en-US"/>
+          </a:p>
+        </p:txBody>
       </p:sp>
       <p:sp>
         <p:nvSpPr>
@@ -6123,7 +6073,7 @@
           <a:bodyPr wrap="square" lIns="0" tIns="0" rIns="0" bIns="0" rtlCol="0" anchor="ctr"/>
           <a:lstStyle/>
           <a:p>
-            <a:pPr indent="0" marL="0">
+            <a:pPr marL="0" indent="0">
               <a:buNone/>
             </a:pPr>
             <a:r>
@@ -6137,9 +6087,6 @@
               </a:rPr>
               <a:t>Request flow: </a:t>
             </a:r>
-            <a:pPr indent="0" marL="0">
-              <a:buNone/>
-            </a:pPr>
             <a:r>
               <a:rPr lang="en-US" sz="1250" dirty="0">
                 <a:solidFill>
@@ -6152,9 +6099,6 @@
               <a:t>UI event → jQuery $.ajax → HTTPS → [requireHttps → helmet → CORS → JSON parser → JWT auth] → Router → Mongoose → Atlas → JSON response → UI update.
 </a:t>
             </a:r>
-            <a:pPr indent="0" marL="0">
-              <a:buNone/>
-            </a:pPr>
             <a:r>
               <a:rPr lang="en-US" sz="1250" b="1" dirty="0">
                 <a:solidFill>
@@ -6166,9 +6110,6 @@
               </a:rPr>
               <a:t>Hosting: </a:t>
             </a:r>
-            <a:pPr indent="0" marL="0">
-              <a:buNone/>
-            </a:pPr>
             <a:r>
               <a:rPr lang="en-US" sz="1250" dirty="0">
                 <a:solidFill>
@@ -6200,6 +6141,7 @@
         <a:solidFill>
           <a:srgbClr val="FFFFFF"/>
         </a:solidFill>
+        <a:effectLst/>
       </p:bgPr>
     </p:bg>
     <p:spTree>
@@ -6240,6 +6182,13 @@
             <a:prstDash val="solid"/>
           </a:ln>
         </p:spPr>
+        <p:txBody>
+          <a:bodyPr/>
+          <a:lstStyle/>
+          <a:p>
+            <a:endParaRPr lang="en-US"/>
+          </a:p>
+        </p:txBody>
       </p:sp>
       <p:sp>
         <p:nvSpPr>
@@ -6262,7 +6211,7 @@
           <a:bodyPr wrap="square" lIns="0" tIns="0" rIns="0" bIns="0" rtlCol="0" anchor="ctr"/>
           <a:lstStyle/>
           <a:p>
-            <a:pPr indent="0" marL="0">
+            <a:pPr marL="0" indent="0">
               <a:buNone/>
             </a:pPr>
             <a:r>
@@ -6301,7 +6250,7 @@
           <a:bodyPr wrap="square" lIns="0" tIns="0" rIns="0" bIns="0" rtlCol="0" anchor="ctr"/>
           <a:lstStyle/>
           <a:p>
-            <a:pPr indent="0" marL="0">
+            <a:pPr marL="0" indent="0">
               <a:buNone/>
             </a:pPr>
             <a:r>
@@ -6335,16 +6284,34 @@
         </p:nvGraphicFramePr>
         <p:xfrm>
           <a:off x="457200" y="1325880"/>
-          <a:ext cx="8229600" cy="914400"/>
+          <a:ext cx="8229600" cy="2743200"/>
         </p:xfrm>
         <a:graphic>
           <a:graphicData uri="http://schemas.openxmlformats.org/drawingml/2006/table">
             <a:tbl>
               <a:tblPr/>
               <a:tblGrid>
-                <a:gridCol w="914400"/>
-                <a:gridCol w="4389120"/>
-                <a:gridCol w="2926080"/>
+                <a:gridCol w="914400">
+                  <a:extLst>
+                    <a:ext uri="{9D8B030D-6E8A-4147-A177-3AD203B41FA5}">
+                      <a16:colId xmlns:a16="http://schemas.microsoft.com/office/drawing/2014/main" val="20000"/>
+                    </a:ext>
+                  </a:extLst>
+                </a:gridCol>
+                <a:gridCol w="4389120">
+                  <a:extLst>
+                    <a:ext uri="{9D8B030D-6E8A-4147-A177-3AD203B41FA5}">
+                      <a16:colId xmlns:a16="http://schemas.microsoft.com/office/drawing/2014/main" val="20001"/>
+                    </a:ext>
+                  </a:extLst>
+                </a:gridCol>
+                <a:gridCol w="2926080">
+                  <a:extLst>
+                    <a:ext uri="{9D8B030D-6E8A-4147-A177-3AD203B41FA5}">
+                      <a16:colId xmlns:a16="http://schemas.microsoft.com/office/drawing/2014/main" val="20002"/>
+                    </a:ext>
+                  </a:extLst>
+                </a:gridCol>
               </a:tblGrid>
               <a:tr h="457200">
                 <a:tc>
@@ -6352,7 +6319,7 @@
                     <a:bodyPr/>
                     <a:lstStyle/>
                     <a:p>
-                      <a:pPr indent="0" marL="0">
+                      <a:pPr marL="0" indent="0">
                         <a:buNone/>
                       </a:pPr>
                       <a:r>
@@ -6373,7 +6340,7 @@
                       </a:endParaRPr>
                     </a:p>
                   </a:txBody>
-                  <a:tcPr marL="91440" marR="91440" marT="45720" marB="45720" anchor="ctr">
+                  <a:tcPr anchor="ctr">
                     <a:lnL w="6350" cap="flat" cmpd="sng" algn="ctr">
                       <a:solidFill>
                         <a:srgbClr val="DDDFEA"/>
@@ -6420,7 +6387,7 @@
                     <a:bodyPr/>
                     <a:lstStyle/>
                     <a:p>
-                      <a:pPr indent="0" marL="0">
+                      <a:pPr marL="0" indent="0">
                         <a:buNone/>
                       </a:pPr>
                       <a:r>
@@ -6441,7 +6408,7 @@
                       </a:endParaRPr>
                     </a:p>
                   </a:txBody>
-                  <a:tcPr marL="91440" marR="91440" marT="45720" marB="45720" anchor="ctr">
+                  <a:tcPr anchor="ctr">
                     <a:lnL w="6350" cap="flat" cmpd="sng" algn="ctr">
                       <a:solidFill>
                         <a:srgbClr val="DDDFEA"/>
@@ -6488,7 +6455,7 @@
                     <a:bodyPr/>
                     <a:lstStyle/>
                     <a:p>
-                      <a:pPr indent="0" marL="0">
+                      <a:pPr marL="0" indent="0">
                         <a:buNone/>
                       </a:pPr>
                       <a:r>
@@ -6509,7 +6476,7 @@
                       </a:endParaRPr>
                     </a:p>
                   </a:txBody>
-                  <a:tcPr marL="91440" marR="91440" marT="45720" marB="45720" anchor="ctr">
+                  <a:tcPr anchor="ctr">
                     <a:lnL w="6350" cap="flat" cmpd="sng" algn="ctr">
                       <a:solidFill>
                         <a:srgbClr val="DDDFEA"/>
@@ -6551,6 +6518,11 @@
                     </a:solidFill>
                   </a:tcPr>
                 </a:tc>
+                <a:extLst>
+                  <a:ext uri="{0D108BD9-81ED-4DB2-BD59-A6C34878D82A}">
+                    <a16:rowId xmlns:a16="http://schemas.microsoft.com/office/drawing/2014/main" val="10000"/>
+                  </a:ext>
+                </a:extLst>
               </a:tr>
               <a:tr h="457200">
                 <a:tc>
@@ -6558,7 +6530,7 @@
                     <a:bodyPr/>
                     <a:lstStyle/>
                     <a:p>
-                      <a:pPr indent="0" marL="0">
+                      <a:pPr marL="0" indent="0">
                         <a:buNone/>
                       </a:pPr>
                       <a:r>
@@ -6579,7 +6551,7 @@
                       </a:endParaRPr>
                     </a:p>
                   </a:txBody>
-                  <a:tcPr marL="91440" marR="91440" marT="45720" marB="45720" anchor="ctr">
+                  <a:tcPr anchor="ctr">
                     <a:lnL w="6350" cap="flat" cmpd="sng" algn="ctr">
                       <a:solidFill>
                         <a:srgbClr val="DDDFEA"/>
@@ -6623,7 +6595,7 @@
                     <a:bodyPr/>
                     <a:lstStyle/>
                     <a:p>
-                      <a:pPr indent="0" marL="0">
+                      <a:pPr marL="0" indent="0">
                         <a:buNone/>
                       </a:pPr>
                       <a:r>
@@ -6644,7 +6616,7 @@
                       </a:endParaRPr>
                     </a:p>
                   </a:txBody>
-                  <a:tcPr marL="91440" marR="91440" marT="45720" marB="45720" anchor="ctr">
+                  <a:tcPr anchor="ctr">
                     <a:lnL w="6350" cap="flat" cmpd="sng" algn="ctr">
                       <a:solidFill>
                         <a:srgbClr val="DDDFEA"/>
@@ -6688,7 +6660,7 @@
                     <a:bodyPr/>
                     <a:lstStyle/>
                     <a:p>
-                      <a:pPr indent="0" marL="0">
+                      <a:pPr marL="0" indent="0">
                         <a:buNone/>
                       </a:pPr>
                       <a:r>
@@ -6709,7 +6681,7 @@
                       </a:endParaRPr>
                     </a:p>
                   </a:txBody>
-                  <a:tcPr marL="91440" marR="91440" marT="45720" marB="45720" anchor="ctr">
+                  <a:tcPr anchor="ctr">
                     <a:lnL w="6350" cap="flat" cmpd="sng" algn="ctr">
                       <a:solidFill>
                         <a:srgbClr val="DDDFEA"/>
@@ -6748,6 +6720,11 @@
                     </a:lnB>
                   </a:tcPr>
                 </a:tc>
+                <a:extLst>
+                  <a:ext uri="{0D108BD9-81ED-4DB2-BD59-A6C34878D82A}">
+                    <a16:rowId xmlns:a16="http://schemas.microsoft.com/office/drawing/2014/main" val="10001"/>
+                  </a:ext>
+                </a:extLst>
               </a:tr>
               <a:tr h="457200">
                 <a:tc>
@@ -6755,7 +6732,7 @@
                     <a:bodyPr/>
                     <a:lstStyle/>
                     <a:p>
-                      <a:pPr indent="0" marL="0">
+                      <a:pPr marL="0" indent="0">
                         <a:buNone/>
                       </a:pPr>
                       <a:r>
@@ -6776,7 +6753,7 @@
                       </a:endParaRPr>
                     </a:p>
                   </a:txBody>
-                  <a:tcPr marL="91440" marR="91440" marT="45720" marB="45720" anchor="ctr">
+                  <a:tcPr anchor="ctr">
                     <a:lnL w="6350" cap="flat" cmpd="sng" algn="ctr">
                       <a:solidFill>
                         <a:srgbClr val="DDDFEA"/>
@@ -6820,7 +6797,7 @@
                     <a:bodyPr/>
                     <a:lstStyle/>
                     <a:p>
-                      <a:pPr indent="0" marL="0">
+                      <a:pPr marL="0" indent="0">
                         <a:buNone/>
                       </a:pPr>
                       <a:r>
@@ -6841,7 +6818,7 @@
                       </a:endParaRPr>
                     </a:p>
                   </a:txBody>
-                  <a:tcPr marL="91440" marR="91440" marT="45720" marB="45720" anchor="ctr">
+                  <a:tcPr anchor="ctr">
                     <a:lnL w="6350" cap="flat" cmpd="sng" algn="ctr">
                       <a:solidFill>
                         <a:srgbClr val="DDDFEA"/>
@@ -6885,7 +6862,7 @@
                     <a:bodyPr/>
                     <a:lstStyle/>
                     <a:p>
-                      <a:pPr indent="0" marL="0">
+                      <a:pPr marL="0" indent="0">
                         <a:buNone/>
                       </a:pPr>
                       <a:r>
@@ -6906,7 +6883,7 @@
                       </a:endParaRPr>
                     </a:p>
                   </a:txBody>
-                  <a:tcPr marL="91440" marR="91440" marT="45720" marB="45720" anchor="ctr">
+                  <a:tcPr anchor="ctr">
                     <a:lnL w="6350" cap="flat" cmpd="sng" algn="ctr">
                       <a:solidFill>
                         <a:srgbClr val="DDDFEA"/>
@@ -6945,6 +6922,11 @@
                     </a:lnB>
                   </a:tcPr>
                 </a:tc>
+                <a:extLst>
+                  <a:ext uri="{0D108BD9-81ED-4DB2-BD59-A6C34878D82A}">
+                    <a16:rowId xmlns:a16="http://schemas.microsoft.com/office/drawing/2014/main" val="10002"/>
+                  </a:ext>
+                </a:extLst>
               </a:tr>
               <a:tr h="457200">
                 <a:tc>
@@ -6952,7 +6934,7 @@
                     <a:bodyPr/>
                     <a:lstStyle/>
                     <a:p>
-                      <a:pPr indent="0" marL="0">
+                      <a:pPr marL="0" indent="0">
                         <a:buNone/>
                       </a:pPr>
                       <a:r>
@@ -6973,7 +6955,7 @@
                       </a:endParaRPr>
                     </a:p>
                   </a:txBody>
-                  <a:tcPr marL="91440" marR="91440" marT="45720" marB="45720" anchor="ctr">
+                  <a:tcPr anchor="ctr">
                     <a:lnL w="6350" cap="flat" cmpd="sng" algn="ctr">
                       <a:solidFill>
                         <a:srgbClr val="DDDFEA"/>
@@ -7017,7 +6999,7 @@
                     <a:bodyPr/>
                     <a:lstStyle/>
                     <a:p>
-                      <a:pPr indent="0" marL="0">
+                      <a:pPr marL="0" indent="0">
                         <a:buNone/>
                       </a:pPr>
                       <a:r>
@@ -7038,7 +7020,7 @@
                       </a:endParaRPr>
                     </a:p>
                   </a:txBody>
-                  <a:tcPr marL="91440" marR="91440" marT="45720" marB="45720" anchor="ctr">
+                  <a:tcPr anchor="ctr">
                     <a:lnL w="6350" cap="flat" cmpd="sng" algn="ctr">
                       <a:solidFill>
                         <a:srgbClr val="DDDFEA"/>
@@ -7082,7 +7064,7 @@
                     <a:bodyPr/>
                     <a:lstStyle/>
                     <a:p>
-                      <a:pPr indent="0" marL="0">
+                      <a:pPr marL="0" indent="0">
                         <a:buNone/>
                       </a:pPr>
                       <a:r>
@@ -7103,7 +7085,7 @@
                       </a:endParaRPr>
                     </a:p>
                   </a:txBody>
-                  <a:tcPr marL="91440" marR="91440" marT="45720" marB="45720" anchor="ctr">
+                  <a:tcPr anchor="ctr">
                     <a:lnL w="6350" cap="flat" cmpd="sng" algn="ctr">
                       <a:solidFill>
                         <a:srgbClr val="DDDFEA"/>
@@ -7142,6 +7124,11 @@
                     </a:lnB>
                   </a:tcPr>
                 </a:tc>
+                <a:extLst>
+                  <a:ext uri="{0D108BD9-81ED-4DB2-BD59-A6C34878D82A}">
+                    <a16:rowId xmlns:a16="http://schemas.microsoft.com/office/drawing/2014/main" val="10003"/>
+                  </a:ext>
+                </a:extLst>
               </a:tr>
               <a:tr h="457200">
                 <a:tc>
@@ -7149,7 +7136,7 @@
                     <a:bodyPr/>
                     <a:lstStyle/>
                     <a:p>
-                      <a:pPr indent="0" marL="0">
+                      <a:pPr marL="0" indent="0">
                         <a:buNone/>
                       </a:pPr>
                       <a:r>
@@ -7170,7 +7157,7 @@
                       </a:endParaRPr>
                     </a:p>
                   </a:txBody>
-                  <a:tcPr marL="91440" marR="91440" marT="45720" marB="45720" anchor="ctr">
+                  <a:tcPr anchor="ctr">
                     <a:lnL w="6350" cap="flat" cmpd="sng" algn="ctr">
                       <a:solidFill>
                         <a:srgbClr val="DDDFEA"/>
@@ -7214,7 +7201,7 @@
                     <a:bodyPr/>
                     <a:lstStyle/>
                     <a:p>
-                      <a:pPr indent="0" marL="0">
+                      <a:pPr marL="0" indent="0">
                         <a:buNone/>
                       </a:pPr>
                       <a:r>
@@ -7235,7 +7222,7 @@
                       </a:endParaRPr>
                     </a:p>
                   </a:txBody>
-                  <a:tcPr marL="91440" marR="91440" marT="45720" marB="45720" anchor="ctr">
+                  <a:tcPr anchor="ctr">
                     <a:lnL w="6350" cap="flat" cmpd="sng" algn="ctr">
                       <a:solidFill>
                         <a:srgbClr val="DDDFEA"/>
@@ -7279,7 +7266,7 @@
                     <a:bodyPr/>
                     <a:lstStyle/>
                     <a:p>
-                      <a:pPr indent="0" marL="0">
+                      <a:pPr marL="0" indent="0">
                         <a:buNone/>
                       </a:pPr>
                       <a:r>
@@ -7300,7 +7287,7 @@
                       </a:endParaRPr>
                     </a:p>
                   </a:txBody>
-                  <a:tcPr marL="91440" marR="91440" marT="45720" marB="45720" anchor="ctr">
+                  <a:tcPr anchor="ctr">
                     <a:lnL w="6350" cap="flat" cmpd="sng" algn="ctr">
                       <a:solidFill>
                         <a:srgbClr val="DDDFEA"/>
@@ -7339,6 +7326,11 @@
                     </a:lnB>
                   </a:tcPr>
                 </a:tc>
+                <a:extLst>
+                  <a:ext uri="{0D108BD9-81ED-4DB2-BD59-A6C34878D82A}">
+                    <a16:rowId xmlns:a16="http://schemas.microsoft.com/office/drawing/2014/main" val="10004"/>
+                  </a:ext>
+                </a:extLst>
               </a:tr>
               <a:tr h="457200">
                 <a:tc>
@@ -7346,7 +7338,7 @@
                     <a:bodyPr/>
                     <a:lstStyle/>
                     <a:p>
-                      <a:pPr indent="0" marL="0">
+                      <a:pPr marL="0" indent="0">
                         <a:buNone/>
                       </a:pPr>
                       <a:r>
@@ -7367,7 +7359,7 @@
                       </a:endParaRPr>
                     </a:p>
                   </a:txBody>
-                  <a:tcPr marL="91440" marR="91440" marT="45720" marB="45720" anchor="ctr">
+                  <a:tcPr anchor="ctr">
                     <a:lnL w="6350" cap="flat" cmpd="sng" algn="ctr">
                       <a:solidFill>
                         <a:srgbClr val="DDDFEA"/>
@@ -7411,7 +7403,7 @@
                     <a:bodyPr/>
                     <a:lstStyle/>
                     <a:p>
-                      <a:pPr indent="0" marL="0">
+                      <a:pPr marL="0" indent="0">
                         <a:buNone/>
                       </a:pPr>
                       <a:r>
@@ -7432,7 +7424,7 @@
                       </a:endParaRPr>
                     </a:p>
                   </a:txBody>
-                  <a:tcPr marL="91440" marR="91440" marT="45720" marB="45720" anchor="ctr">
+                  <a:tcPr anchor="ctr">
                     <a:lnL w="6350" cap="flat" cmpd="sng" algn="ctr">
                       <a:solidFill>
                         <a:srgbClr val="DDDFEA"/>
@@ -7476,7 +7468,7 @@
                     <a:bodyPr/>
                     <a:lstStyle/>
                     <a:p>
-                      <a:pPr indent="0" marL="0">
+                      <a:pPr marL="0" indent="0">
                         <a:buNone/>
                       </a:pPr>
                       <a:r>
@@ -7497,7 +7489,7 @@
                       </a:endParaRPr>
                     </a:p>
                   </a:txBody>
-                  <a:tcPr marL="91440" marR="91440" marT="45720" marB="45720" anchor="ctr">
+                  <a:tcPr anchor="ctr">
                     <a:lnL w="6350" cap="flat" cmpd="sng" algn="ctr">
                       <a:solidFill>
                         <a:srgbClr val="DDDFEA"/>
@@ -7536,6 +7528,11 @@
                     </a:lnB>
                   </a:tcPr>
                 </a:tc>
+                <a:extLst>
+                  <a:ext uri="{0D108BD9-81ED-4DB2-BD59-A6C34878D82A}">
+                    <a16:rowId xmlns:a16="http://schemas.microsoft.com/office/drawing/2014/main" val="10005"/>
+                  </a:ext>
+                </a:extLst>
               </a:tr>
             </a:tbl>
           </a:graphicData>
@@ -7562,7 +7559,7 @@
           <a:bodyPr wrap="square" lIns="0" tIns="0" rIns="0" bIns="0" rtlCol="0" anchor="ctr"/>
           <a:lstStyle/>
           <a:p>
-            <a:pPr indent="0" marL="0">
+            <a:pPr marL="0" indent="0">
               <a:buNone/>
             </a:pPr>
             <a:r>
@@ -7596,6 +7593,7 @@
         <a:solidFill>
           <a:srgbClr val="FFFFFF"/>
         </a:solidFill>
+        <a:effectLst/>
       </p:bgPr>
     </p:bg>
     <p:spTree>
@@ -7636,6 +7634,13 @@
             <a:prstDash val="solid"/>
           </a:ln>
         </p:spPr>
+        <p:txBody>
+          <a:bodyPr/>
+          <a:lstStyle/>
+          <a:p>
+            <a:endParaRPr lang="en-US"/>
+          </a:p>
+        </p:txBody>
       </p:sp>
       <p:sp>
         <p:nvSpPr>
@@ -7658,7 +7663,7 @@
           <a:bodyPr wrap="square" lIns="0" tIns="0" rIns="0" bIns="0" rtlCol="0" anchor="ctr"/>
           <a:lstStyle/>
           <a:p>
-            <a:pPr indent="0" marL="0">
+            <a:pPr marL="0" indent="0">
               <a:buNone/>
             </a:pPr>
             <a:r>
@@ -7697,7 +7702,7 @@
           <a:bodyPr wrap="square" lIns="0" tIns="0" rIns="0" bIns="0" rtlCol="0" anchor="ctr"/>
           <a:lstStyle/>
           <a:p>
-            <a:pPr indent="0" marL="0">
+            <a:pPr marL="0" indent="0">
               <a:buNone/>
             </a:pPr>
             <a:r>
@@ -7717,22 +7722,21 @@
       </p:sp>
       <p:pic>
         <p:nvPicPr>
-          <p:cNvPr id="5" name="Image 0" descr="/home/claude/moodstreak/docs/screenshots/01-login.png">    </p:cNvPr>
+          <p:cNvPr id="5" name="Image 0"/>
           <p:cNvPicPr>
             <a:picLocks noChangeAspect="1"/>
           </p:cNvPicPr>
           <p:nvPr/>
         </p:nvPicPr>
         <p:blipFill>
-          <a:blip r:embed="rId1"/>
-          <a:stretch>
-            <a:fillRect/>
-          </a:stretch>
+          <a:blip r:embed="rId3"/>
+          <a:srcRect/>
+          <a:stretch/>
         </p:blipFill>
         <p:spPr>
           <a:xfrm>
-            <a:off x="411480" y="1188720"/>
-            <a:ext cx="1500032" cy="3246120"/>
+            <a:off x="413466" y="1188720"/>
+            <a:ext cx="1496060" cy="3246120"/>
           </a:xfrm>
           <a:prstGeom prst="rect">
             <a:avLst/>
@@ -7760,7 +7764,7 @@
           <a:bodyPr wrap="square" lIns="0" tIns="0" rIns="0" bIns="0" rtlCol="0" anchor="ctr"/>
           <a:lstStyle/>
           <a:p>
-            <a:pPr algn="ctr" indent="0" marL="0">
+            <a:pPr marL="0" indent="0" algn="ctr">
               <a:buNone/>
             </a:pPr>
             <a:r>
@@ -7780,22 +7784,21 @@
       </p:sp>
       <p:pic>
         <p:nvPicPr>
-          <p:cNvPr id="7" name="Image 1" descr="/home/claude/moodstreak/docs/screenshots/03-today.png">    </p:cNvPr>
+          <p:cNvPr id="7" name="Image 1"/>
           <p:cNvPicPr>
             <a:picLocks noChangeAspect="1"/>
           </p:cNvPicPr>
           <p:nvPr/>
         </p:nvPicPr>
         <p:blipFill>
-          <a:blip r:embed="rId2"/>
-          <a:stretch>
-            <a:fillRect/>
-          </a:stretch>
+          <a:blip r:embed="rId4"/>
+          <a:srcRect/>
+          <a:stretch/>
         </p:blipFill>
         <p:spPr>
           <a:xfrm>
-            <a:off x="2075688" y="1188720"/>
-            <a:ext cx="1500032" cy="3246120"/>
+            <a:off x="2077674" y="1188720"/>
+            <a:ext cx="1496060" cy="3246120"/>
           </a:xfrm>
           <a:prstGeom prst="rect">
             <a:avLst/>
@@ -7823,7 +7826,7 @@
           <a:bodyPr wrap="square" lIns="0" tIns="0" rIns="0" bIns="0" rtlCol="0" anchor="ctr"/>
           <a:lstStyle/>
           <a:p>
-            <a:pPr algn="ctr" indent="0" marL="0">
+            <a:pPr marL="0" indent="0" algn="ctr">
               <a:buNone/>
             </a:pPr>
             <a:r>
@@ -7843,22 +7846,21 @@
       </p:sp>
       <p:pic>
         <p:nvPicPr>
-          <p:cNvPr id="9" name="Image 2" descr="/home/claude/moodstreak/docs/screenshots/04-today-logged.png">    </p:cNvPr>
+          <p:cNvPr id="9" name="Image 2"/>
           <p:cNvPicPr>
             <a:picLocks noChangeAspect="1"/>
           </p:cNvPicPr>
           <p:nvPr/>
         </p:nvPicPr>
         <p:blipFill>
-          <a:blip r:embed="rId3"/>
-          <a:stretch>
-            <a:fillRect/>
-          </a:stretch>
+          <a:blip r:embed="rId5"/>
+          <a:srcRect/>
+          <a:stretch/>
         </p:blipFill>
         <p:spPr>
           <a:xfrm>
-            <a:off x="3739896" y="1188720"/>
-            <a:ext cx="1500032" cy="3246120"/>
+            <a:off x="3741882" y="1188720"/>
+            <a:ext cx="1496060" cy="3246120"/>
           </a:xfrm>
           <a:prstGeom prst="rect">
             <a:avLst/>
@@ -7886,7 +7888,7 @@
           <a:bodyPr wrap="square" lIns="0" tIns="0" rIns="0" bIns="0" rtlCol="0" anchor="ctr"/>
           <a:lstStyle/>
           <a:p>
-            <a:pPr algn="ctr" indent="0" marL="0">
+            <a:pPr marL="0" indent="0" algn="ctr">
               <a:buNone/>
             </a:pPr>
             <a:r>
@@ -7906,22 +7908,21 @@
       </p:sp>
       <p:pic>
         <p:nvPicPr>
-          <p:cNvPr id="11" name="Image 3" descr="/home/claude/moodstreak/docs/screenshots/06-insights.png">    </p:cNvPr>
+          <p:cNvPr id="11" name="Image 3"/>
           <p:cNvPicPr>
             <a:picLocks noChangeAspect="1"/>
           </p:cNvPicPr>
           <p:nvPr/>
         </p:nvPicPr>
         <p:blipFill>
-          <a:blip r:embed="rId4"/>
-          <a:stretch>
-            <a:fillRect/>
-          </a:stretch>
+          <a:blip r:embed="rId6"/>
+          <a:srcRect/>
+          <a:stretch/>
         </p:blipFill>
         <p:spPr>
           <a:xfrm>
-            <a:off x="5404104" y="1188720"/>
-            <a:ext cx="1500032" cy="3246120"/>
+            <a:off x="5406090" y="1188720"/>
+            <a:ext cx="1496060" cy="3246120"/>
           </a:xfrm>
           <a:prstGeom prst="rect">
             <a:avLst/>
@@ -7949,7 +7950,7 @@
           <a:bodyPr wrap="square" lIns="0" tIns="0" rIns="0" bIns="0" rtlCol="0" anchor="ctr"/>
           <a:lstStyle/>
           <a:p>
-            <a:pPr algn="ctr" indent="0" marL="0">
+            <a:pPr marL="0" indent="0" algn="ctr">
               <a:buNone/>
             </a:pPr>
             <a:r>
@@ -7969,22 +7970,21 @@
       </p:sp>
       <p:pic>
         <p:nvPicPr>
-          <p:cNvPr id="13" name="Image 4" descr="/home/claude/moodstreak/docs/screenshots/05-add-habit.png">    </p:cNvPr>
+          <p:cNvPr id="13" name="Image 4"/>
           <p:cNvPicPr>
             <a:picLocks noChangeAspect="1"/>
           </p:cNvPicPr>
           <p:nvPr/>
         </p:nvPicPr>
         <p:blipFill>
-          <a:blip r:embed="rId5"/>
-          <a:stretch>
-            <a:fillRect/>
-          </a:stretch>
+          <a:blip r:embed="rId7"/>
+          <a:srcRect/>
+          <a:stretch/>
         </p:blipFill>
         <p:spPr>
           <a:xfrm>
-            <a:off x="7068312" y="1188720"/>
-            <a:ext cx="1500032" cy="3246120"/>
+            <a:off x="7070298" y="1188720"/>
+            <a:ext cx="1496060" cy="3246120"/>
           </a:xfrm>
           <a:prstGeom prst="rect">
             <a:avLst/>
@@ -8012,7 +8012,7 @@
           <a:bodyPr wrap="square" lIns="0" tIns="0" rIns="0" bIns="0" rtlCol="0" anchor="ctr"/>
           <a:lstStyle/>
           <a:p>
-            <a:pPr algn="ctr" indent="0" marL="0">
+            <a:pPr marL="0" indent="0" algn="ctr">
               <a:buNone/>
             </a:pPr>
             <a:r>
@@ -8046,6 +8046,7 @@
         <a:solidFill>
           <a:srgbClr val="FFFFFF"/>
         </a:solidFill>
+        <a:effectLst/>
       </p:bgPr>
     </p:bg>
     <p:spTree>
@@ -8086,6 +8087,13 @@
             <a:prstDash val="solid"/>
           </a:ln>
         </p:spPr>
+        <p:txBody>
+          <a:bodyPr/>
+          <a:lstStyle/>
+          <a:p>
+            <a:endParaRPr lang="en-US"/>
+          </a:p>
+        </p:txBody>
       </p:sp>
       <p:sp>
         <p:nvSpPr>
@@ -8108,7 +8116,7 @@
           <a:bodyPr wrap="square" lIns="0" tIns="0" rIns="0" bIns="0" rtlCol="0" anchor="ctr"/>
           <a:lstStyle/>
           <a:p>
-            <a:pPr indent="0" marL="0">
+            <a:pPr marL="0" indent="0">
               <a:buNone/>
             </a:pPr>
             <a:r>
@@ -8147,7 +8155,7 @@
           <a:bodyPr wrap="square" lIns="0" tIns="0" rIns="0" bIns="0" rtlCol="0" anchor="ctr"/>
           <a:lstStyle/>
           <a:p>
-            <a:pPr indent="0" marL="0">
+            <a:pPr marL="0" indent="0">
               <a:buNone/>
             </a:pPr>
             <a:r>
@@ -8191,6 +8199,13 @@
             <a:prstDash val="solid"/>
           </a:ln>
         </p:spPr>
+        <p:txBody>
+          <a:bodyPr/>
+          <a:lstStyle/>
+          <a:p>
+            <a:endParaRPr lang="en-US"/>
+          </a:p>
+        </p:txBody>
       </p:sp>
       <p:sp>
         <p:nvSpPr>
@@ -8213,7 +8228,7 @@
           <a:bodyPr wrap="square" lIns="0" tIns="0" rIns="0" bIns="0" rtlCol="0" anchor="ctr"/>
           <a:lstStyle/>
           <a:p>
-            <a:pPr indent="0" marL="0">
+            <a:pPr marL="0" indent="0">
               <a:buNone/>
             </a:pPr>
             <a:r>
@@ -8252,7 +8267,7 @@
           <a:bodyPr wrap="square" lIns="0" tIns="0" rIns="0" bIns="0" rtlCol="0" anchor="ctr"/>
           <a:lstStyle/>
           <a:p>
-            <a:pPr indent="0" marL="0">
+            <a:pPr marL="0" indent="0">
               <a:buNone/>
             </a:pPr>
             <a:r>
@@ -8423,6 +8438,13 @@
             <a:prstDash val="solid"/>
           </a:ln>
         </p:spPr>
+        <p:txBody>
+          <a:bodyPr/>
+          <a:lstStyle/>
+          <a:p>
+            <a:endParaRPr lang="en-US"/>
+          </a:p>
+        </p:txBody>
       </p:sp>
       <p:sp>
         <p:nvSpPr>
@@ -8445,7 +8467,7 @@
           <a:bodyPr wrap="square" lIns="0" tIns="0" rIns="0" bIns="0" rtlCol="0" anchor="ctr"/>
           <a:lstStyle/>
           <a:p>
-            <a:pPr indent="0" marL="0">
+            <a:pPr marL="0" indent="0">
               <a:buNone/>
             </a:pPr>
             <a:r>
@@ -8484,7 +8506,7 @@
           <a:bodyPr wrap="square" lIns="0" tIns="0" rIns="0" bIns="0" rtlCol="0" anchor="t"/>
           <a:lstStyle/>
           <a:p>
-            <a:pPr indent="0" marL="0">
+            <a:pPr marL="0" indent="0">
               <a:spcAft>
                 <a:spcPts val="300"/>
               </a:spcAft>
@@ -8501,12 +8523,6 @@
               </a:rPr>
               <a:t>✔ </a:t>
             </a:r>
-            <a:pPr indent="0" marL="0">
-              <a:spcAft>
-                <a:spcPts val="300"/>
-              </a:spcAft>
-              <a:buNone/>
-            </a:pPr>
             <a:r>
               <a:rPr lang="en-US" sz="1200" dirty="0">
                 <a:solidFill>
@@ -8521,7 +8537,7 @@
             <a:endParaRPr lang="en-US" sz="1200" dirty="0"/>
           </a:p>
           <a:p>
-            <a:pPr indent="0" marL="0">
+            <a:pPr marL="0" indent="0">
               <a:spcAft>
                 <a:spcPts val="300"/>
               </a:spcAft>
@@ -8538,12 +8554,6 @@
               </a:rPr>
               <a:t>✔ </a:t>
             </a:r>
-            <a:pPr indent="0" marL="0">
-              <a:spcAft>
-                <a:spcPts val="300"/>
-              </a:spcAft>
-              <a:buNone/>
-            </a:pPr>
             <a:r>
               <a:rPr lang="en-US" sz="1200" dirty="0">
                 <a:solidFill>
@@ -8558,7 +8568,7 @@
             <a:endParaRPr lang="en-US" sz="1200" dirty="0"/>
           </a:p>
           <a:p>
-            <a:pPr indent="0" marL="0">
+            <a:pPr marL="0" indent="0">
               <a:spcAft>
                 <a:spcPts val="300"/>
               </a:spcAft>
@@ -8575,12 +8585,6 @@
               </a:rPr>
               <a:t>✔ </a:t>
             </a:r>
-            <a:pPr indent="0" marL="0">
-              <a:spcAft>
-                <a:spcPts val="300"/>
-              </a:spcAft>
-              <a:buNone/>
-            </a:pPr>
             <a:r>
               <a:rPr lang="en-US" sz="1200" dirty="0">
                 <a:solidFill>
@@ -8595,7 +8599,7 @@
             <a:endParaRPr lang="en-US" sz="1200" dirty="0"/>
           </a:p>
           <a:p>
-            <a:pPr indent="0" marL="0">
+            <a:pPr marL="0" indent="0">
               <a:spcAft>
                 <a:spcPts val="300"/>
               </a:spcAft>
@@ -8612,12 +8616,6 @@
               </a:rPr>
               <a:t>✔ </a:t>
             </a:r>
-            <a:pPr indent="0" marL="0">
-              <a:spcAft>
-                <a:spcPts val="300"/>
-              </a:spcAft>
-              <a:buNone/>
-            </a:pPr>
             <a:r>
               <a:rPr lang="en-US" sz="1200" dirty="0">
                 <a:solidFill>
@@ -8632,7 +8630,7 @@
             <a:endParaRPr lang="en-US" sz="1200" dirty="0"/>
           </a:p>
           <a:p>
-            <a:pPr indent="0" marL="0">
+            <a:pPr marL="0" indent="0">
               <a:spcAft>
                 <a:spcPts val="300"/>
               </a:spcAft>
@@ -8649,12 +8647,6 @@
               </a:rPr>
               <a:t>✔ </a:t>
             </a:r>
-            <a:pPr indent="0" marL="0">
-              <a:spcAft>
-                <a:spcPts val="300"/>
-              </a:spcAft>
-              <a:buNone/>
-            </a:pPr>
             <a:r>
               <a:rPr lang="en-US" sz="1200" dirty="0">
                 <a:solidFill>
@@ -8669,7 +8661,7 @@
             <a:endParaRPr lang="en-US" sz="1200" dirty="0"/>
           </a:p>
           <a:p>
-            <a:pPr indent="0" marL="0">
+            <a:pPr marL="0" indent="0">
               <a:spcAft>
                 <a:spcPts val="300"/>
               </a:spcAft>
@@ -8686,12 +8678,6 @@
               </a:rPr>
               <a:t>✔ </a:t>
             </a:r>
-            <a:pPr indent="0" marL="0">
-              <a:spcAft>
-                <a:spcPts val="300"/>
-              </a:spcAft>
-              <a:buNone/>
-            </a:pPr>
             <a:r>
               <a:rPr lang="en-US" sz="1200" dirty="0">
                 <a:solidFill>
@@ -8706,7 +8692,7 @@
             <a:endParaRPr lang="en-US" sz="1200" dirty="0"/>
           </a:p>
           <a:p>
-            <a:pPr indent="0" marL="0">
+            <a:pPr marL="0" indent="0">
               <a:spcAft>
                 <a:spcPts val="300"/>
               </a:spcAft>
@@ -8723,12 +8709,6 @@
               </a:rPr>
               <a:t>✔ </a:t>
             </a:r>
-            <a:pPr indent="0" marL="0">
-              <a:spcAft>
-                <a:spcPts val="300"/>
-              </a:spcAft>
-              <a:buNone/>
-            </a:pPr>
             <a:r>
               <a:rPr lang="en-US" sz="1200" dirty="0">
                 <a:solidFill>
@@ -8743,7 +8723,7 @@
             <a:endParaRPr lang="en-US" sz="1200" dirty="0"/>
           </a:p>
           <a:p>
-            <a:pPr indent="0" marL="0">
+            <a:pPr marL="0" indent="0">
               <a:spcAft>
                 <a:spcPts val="300"/>
               </a:spcAft>
@@ -8760,12 +8740,6 @@
               </a:rPr>
               <a:t>✔ </a:t>
             </a:r>
-            <a:pPr indent="0" marL="0">
-              <a:spcAft>
-                <a:spcPts val="300"/>
-              </a:spcAft>
-              <a:buNone/>
-            </a:pPr>
             <a:r>
               <a:rPr lang="en-US" sz="1200" dirty="0">
                 <a:solidFill>
@@ -8780,7 +8754,7 @@
             <a:endParaRPr lang="en-US" sz="1200" dirty="0"/>
           </a:p>
           <a:p>
-            <a:pPr indent="0" marL="0">
+            <a:pPr marL="0" indent="0">
               <a:spcAft>
                 <a:spcPts val="300"/>
               </a:spcAft>
@@ -8797,12 +8771,6 @@
               </a:rPr>
               <a:t>✔ </a:t>
             </a:r>
-            <a:pPr indent="0" marL="0">
-              <a:spcAft>
-                <a:spcPts val="300"/>
-              </a:spcAft>
-              <a:buNone/>
-            </a:pPr>
             <a:r>
               <a:rPr lang="en-US" sz="1200" dirty="0">
                 <a:solidFill>
@@ -8834,6 +8802,7 @@
         <a:solidFill>
           <a:srgbClr val="FFFFFF"/>
         </a:solidFill>
+        <a:effectLst/>
       </p:bgPr>
     </p:bg>
     <p:spTree>
@@ -8874,6 +8843,13 @@
             <a:prstDash val="solid"/>
           </a:ln>
         </p:spPr>
+        <p:txBody>
+          <a:bodyPr/>
+          <a:lstStyle/>
+          <a:p>
+            <a:endParaRPr lang="en-US"/>
+          </a:p>
+        </p:txBody>
       </p:sp>
       <p:sp>
         <p:nvSpPr>
@@ -8896,7 +8872,7 @@
           <a:bodyPr wrap="square" lIns="0" tIns="0" rIns="0" bIns="0" rtlCol="0" anchor="ctr"/>
           <a:lstStyle/>
           <a:p>
-            <a:pPr indent="0" marL="0">
+            <a:pPr marL="0" indent="0">
               <a:buNone/>
             </a:pPr>
             <a:r>
@@ -8935,7 +8911,7 @@
           <a:bodyPr wrap="square" lIns="0" tIns="0" rIns="0" bIns="0" rtlCol="0" anchor="ctr"/>
           <a:lstStyle/>
           <a:p>
-            <a:pPr indent="0" marL="0">
+            <a:pPr marL="0" indent="0">
               <a:buNone/>
             </a:pPr>
             <a:r>
@@ -8969,16 +8945,34 @@
         </p:nvGraphicFramePr>
         <p:xfrm>
           <a:off x="457200" y="1280160"/>
-          <a:ext cx="8229600" cy="914400"/>
+          <a:ext cx="8229600" cy="3429000"/>
         </p:xfrm>
         <a:graphic>
           <a:graphicData uri="http://schemas.openxmlformats.org/drawingml/2006/table">
             <a:tbl>
               <a:tblPr/>
               <a:tblGrid>
-                <a:gridCol w="3017520"/>
-                <a:gridCol w="1188720"/>
-                <a:gridCol w="4023360"/>
+                <a:gridCol w="3017520">
+                  <a:extLst>
+                    <a:ext uri="{9D8B030D-6E8A-4147-A177-3AD203B41FA5}">
+                      <a16:colId xmlns:a16="http://schemas.microsoft.com/office/drawing/2014/main" val="20000"/>
+                    </a:ext>
+                  </a:extLst>
+                </a:gridCol>
+                <a:gridCol w="1188720">
+                  <a:extLst>
+                    <a:ext uri="{9D8B030D-6E8A-4147-A177-3AD203B41FA5}">
+                      <a16:colId xmlns:a16="http://schemas.microsoft.com/office/drawing/2014/main" val="20001"/>
+                    </a:ext>
+                  </a:extLst>
+                </a:gridCol>
+                <a:gridCol w="4023360">
+                  <a:extLst>
+                    <a:ext uri="{9D8B030D-6E8A-4147-A177-3AD203B41FA5}">
+                      <a16:colId xmlns:a16="http://schemas.microsoft.com/office/drawing/2014/main" val="20002"/>
+                    </a:ext>
+                  </a:extLst>
+                </a:gridCol>
               </a:tblGrid>
               <a:tr h="342900">
                 <a:tc>
@@ -8986,7 +8980,7 @@
                     <a:bodyPr/>
                     <a:lstStyle/>
                     <a:p>
-                      <a:pPr indent="0" marL="0">
+                      <a:pPr marL="0" indent="0">
                         <a:buNone/>
                       </a:pPr>
                       <a:r>
@@ -9007,7 +9001,7 @@
                       </a:endParaRPr>
                     </a:p>
                   </a:txBody>
-                  <a:tcPr marL="91440" marR="91440" marT="45720" marB="45720" anchor="ctr">
+                  <a:tcPr anchor="ctr">
                     <a:lnL w="6350" cap="flat" cmpd="sng" algn="ctr">
                       <a:solidFill>
                         <a:srgbClr val="DDDFEA"/>
@@ -9054,7 +9048,7 @@
                     <a:bodyPr/>
                     <a:lstStyle/>
                     <a:p>
-                      <a:pPr indent="0" marL="0">
+                      <a:pPr marL="0" indent="0">
                         <a:buNone/>
                       </a:pPr>
                       <a:r>
@@ -9075,7 +9069,7 @@
                       </a:endParaRPr>
                     </a:p>
                   </a:txBody>
-                  <a:tcPr marL="91440" marR="91440" marT="45720" marB="45720" anchor="ctr">
+                  <a:tcPr anchor="ctr">
                     <a:lnL w="6350" cap="flat" cmpd="sng" algn="ctr">
                       <a:solidFill>
                         <a:srgbClr val="DDDFEA"/>
@@ -9122,7 +9116,7 @@
                     <a:bodyPr/>
                     <a:lstStyle/>
                     <a:p>
-                      <a:pPr indent="0" marL="0">
+                      <a:pPr marL="0" indent="0">
                         <a:buNone/>
                       </a:pPr>
                       <a:r>
@@ -9143,7 +9137,7 @@
                       </a:endParaRPr>
                     </a:p>
                   </a:txBody>
-                  <a:tcPr marL="91440" marR="91440" marT="45720" marB="45720" anchor="ctr">
+                  <a:tcPr anchor="ctr">
                     <a:lnL w="6350" cap="flat" cmpd="sng" algn="ctr">
                       <a:solidFill>
                         <a:srgbClr val="DDDFEA"/>
@@ -9185,6 +9179,11 @@
                     </a:solidFill>
                   </a:tcPr>
                 </a:tc>
+                <a:extLst>
+                  <a:ext uri="{0D108BD9-81ED-4DB2-BD59-A6C34878D82A}">
+                    <a16:rowId xmlns:a16="http://schemas.microsoft.com/office/drawing/2014/main" val="10000"/>
+                  </a:ext>
+                </a:extLst>
               </a:tr>
               <a:tr h="342900">
                 <a:tc>
@@ -9192,7 +9191,7 @@
                     <a:bodyPr/>
                     <a:lstStyle/>
                     <a:p>
-                      <a:pPr indent="0" marL="0">
+                      <a:pPr marL="0" indent="0">
                         <a:buNone/>
                       </a:pPr>
                       <a:r>
@@ -9213,7 +9212,7 @@
                       </a:endParaRPr>
                     </a:p>
                   </a:txBody>
-                  <a:tcPr marL="91440" marR="91440" marT="45720" marB="45720" anchor="ctr">
+                  <a:tcPr anchor="ctr">
                     <a:lnL w="6350" cap="flat" cmpd="sng" algn="ctr">
                       <a:solidFill>
                         <a:srgbClr val="DDDFEA"/>
@@ -9257,7 +9256,7 @@
                     <a:bodyPr/>
                     <a:lstStyle/>
                     <a:p>
-                      <a:pPr algn="ctr" indent="0" marL="0">
+                      <a:pPr marL="0" indent="0" algn="ctr">
                         <a:buNone/>
                       </a:pPr>
                       <a:r>
@@ -9278,7 +9277,7 @@
                       </a:endParaRPr>
                     </a:p>
                   </a:txBody>
-                  <a:tcPr marL="91440" marR="91440" marT="45720" marB="45720" anchor="ctr">
+                  <a:tcPr anchor="ctr">
                     <a:lnL w="6350" cap="flat" cmpd="sng" algn="ctr">
                       <a:solidFill>
                         <a:srgbClr val="DDDFEA"/>
@@ -9322,7 +9321,7 @@
                     <a:bodyPr/>
                     <a:lstStyle/>
                     <a:p>
-                      <a:pPr indent="0" marL="0">
+                      <a:pPr marL="0" indent="0">
                         <a:buNone/>
                       </a:pPr>
                       <a:r>
@@ -9343,7 +9342,7 @@
                       </a:endParaRPr>
                     </a:p>
                   </a:txBody>
-                  <a:tcPr marL="91440" marR="91440" marT="45720" marB="45720" anchor="ctr">
+                  <a:tcPr anchor="ctr">
                     <a:lnL w="6350" cap="flat" cmpd="sng" algn="ctr">
                       <a:solidFill>
                         <a:srgbClr val="DDDFEA"/>
@@ -9382,6 +9381,11 @@
                     </a:lnB>
                   </a:tcPr>
                 </a:tc>
+                <a:extLst>
+                  <a:ext uri="{0D108BD9-81ED-4DB2-BD59-A6C34878D82A}">
+                    <a16:rowId xmlns:a16="http://schemas.microsoft.com/office/drawing/2014/main" val="10001"/>
+                  </a:ext>
+                </a:extLst>
               </a:tr>
               <a:tr h="342900">
                 <a:tc>
@@ -9389,7 +9393,7 @@
                     <a:bodyPr/>
                     <a:lstStyle/>
                     <a:p>
-                      <a:pPr indent="0" marL="0">
+                      <a:pPr marL="0" indent="0">
                         <a:buNone/>
                       </a:pPr>
                       <a:r>
@@ -9410,7 +9414,7 @@
                       </a:endParaRPr>
                     </a:p>
                   </a:txBody>
-                  <a:tcPr marL="91440" marR="91440" marT="45720" marB="45720" anchor="ctr">
+                  <a:tcPr anchor="ctr">
                     <a:lnL w="6350" cap="flat" cmpd="sng" algn="ctr">
                       <a:solidFill>
                         <a:srgbClr val="DDDFEA"/>
@@ -9454,7 +9458,7 @@
                     <a:bodyPr/>
                     <a:lstStyle/>
                     <a:p>
-                      <a:pPr algn="ctr" indent="0" marL="0">
+                      <a:pPr marL="0" indent="0" algn="ctr">
                         <a:buNone/>
                       </a:pPr>
                       <a:r>
@@ -9475,7 +9479,7 @@
                       </a:endParaRPr>
                     </a:p>
                   </a:txBody>
-                  <a:tcPr marL="91440" marR="91440" marT="45720" marB="45720" anchor="ctr">
+                  <a:tcPr anchor="ctr">
                     <a:lnL w="6350" cap="flat" cmpd="sng" algn="ctr">
                       <a:solidFill>
                         <a:srgbClr val="DDDFEA"/>
@@ -9519,7 +9523,7 @@
                     <a:bodyPr/>
                     <a:lstStyle/>
                     <a:p>
-                      <a:pPr indent="0" marL="0">
+                      <a:pPr marL="0" indent="0">
                         <a:buNone/>
                       </a:pPr>
                       <a:r>
@@ -9540,7 +9544,7 @@
                       </a:endParaRPr>
                     </a:p>
                   </a:txBody>
-                  <a:tcPr marL="91440" marR="91440" marT="45720" marB="45720" anchor="ctr">
+                  <a:tcPr anchor="ctr">
                     <a:lnL w="6350" cap="flat" cmpd="sng" algn="ctr">
                       <a:solidFill>
                         <a:srgbClr val="DDDFEA"/>
@@ -9579,6 +9583,11 @@
                     </a:lnB>
                   </a:tcPr>
                 </a:tc>
+                <a:extLst>
+                  <a:ext uri="{0D108BD9-81ED-4DB2-BD59-A6C34878D82A}">
+                    <a16:rowId xmlns:a16="http://schemas.microsoft.com/office/drawing/2014/main" val="10002"/>
+                  </a:ext>
+                </a:extLst>
               </a:tr>
               <a:tr h="342900">
                 <a:tc>
@@ -9586,7 +9595,7 @@
                     <a:bodyPr/>
                     <a:lstStyle/>
                     <a:p>
-                      <a:pPr indent="0" marL="0">
+                      <a:pPr marL="0" indent="0">
                         <a:buNone/>
                       </a:pPr>
                       <a:r>
@@ -9607,7 +9616,7 @@
                       </a:endParaRPr>
                     </a:p>
                   </a:txBody>
-                  <a:tcPr marL="91440" marR="91440" marT="45720" marB="45720" anchor="ctr">
+                  <a:tcPr anchor="ctr">
                     <a:lnL w="6350" cap="flat" cmpd="sng" algn="ctr">
                       <a:solidFill>
                         <a:srgbClr val="DDDFEA"/>
@@ -9651,7 +9660,7 @@
                     <a:bodyPr/>
                     <a:lstStyle/>
                     <a:p>
-                      <a:pPr algn="ctr" indent="0" marL="0">
+                      <a:pPr marL="0" indent="0" algn="ctr">
                         <a:buNone/>
                       </a:pPr>
                       <a:r>
@@ -9672,7 +9681,7 @@
                       </a:endParaRPr>
                     </a:p>
                   </a:txBody>
-                  <a:tcPr marL="91440" marR="91440" marT="45720" marB="45720" anchor="ctr">
+                  <a:tcPr anchor="ctr">
                     <a:lnL w="6350" cap="flat" cmpd="sng" algn="ctr">
                       <a:solidFill>
                         <a:srgbClr val="DDDFEA"/>
@@ -9716,7 +9725,7 @@
                     <a:bodyPr/>
                     <a:lstStyle/>
                     <a:p>
-                      <a:pPr indent="0" marL="0">
+                      <a:pPr marL="0" indent="0">
                         <a:buNone/>
                       </a:pPr>
                       <a:r>
@@ -9737,7 +9746,7 @@
                       </a:endParaRPr>
                     </a:p>
                   </a:txBody>
-                  <a:tcPr marL="91440" marR="91440" marT="45720" marB="45720" anchor="ctr">
+                  <a:tcPr anchor="ctr">
                     <a:lnL w="6350" cap="flat" cmpd="sng" algn="ctr">
                       <a:solidFill>
                         <a:srgbClr val="DDDFEA"/>
@@ -9776,6 +9785,11 @@
                     </a:lnB>
                   </a:tcPr>
                 </a:tc>
+                <a:extLst>
+                  <a:ext uri="{0D108BD9-81ED-4DB2-BD59-A6C34878D82A}">
+                    <a16:rowId xmlns:a16="http://schemas.microsoft.com/office/drawing/2014/main" val="10003"/>
+                  </a:ext>
+                </a:extLst>
               </a:tr>
               <a:tr h="342900">
                 <a:tc>
@@ -9783,7 +9797,7 @@
                     <a:bodyPr/>
                     <a:lstStyle/>
                     <a:p>
-                      <a:pPr indent="0" marL="0">
+                      <a:pPr marL="0" indent="0">
                         <a:buNone/>
                       </a:pPr>
                       <a:r>
@@ -9804,7 +9818,7 @@
                       </a:endParaRPr>
                     </a:p>
                   </a:txBody>
-                  <a:tcPr marL="91440" marR="91440" marT="45720" marB="45720" anchor="ctr">
+                  <a:tcPr anchor="ctr">
                     <a:lnL w="6350" cap="flat" cmpd="sng" algn="ctr">
                       <a:solidFill>
                         <a:srgbClr val="DDDFEA"/>
@@ -9848,7 +9862,7 @@
                     <a:bodyPr/>
                     <a:lstStyle/>
                     <a:p>
-                      <a:pPr algn="ctr" indent="0" marL="0">
+                      <a:pPr marL="0" indent="0" algn="ctr">
                         <a:buNone/>
                       </a:pPr>
                       <a:r>
@@ -9869,7 +9883,7 @@
                       </a:endParaRPr>
                     </a:p>
                   </a:txBody>
-                  <a:tcPr marL="91440" marR="91440" marT="45720" marB="45720" anchor="ctr">
+                  <a:tcPr anchor="ctr">
                     <a:lnL w="6350" cap="flat" cmpd="sng" algn="ctr">
                       <a:solidFill>
                         <a:srgbClr val="DDDFEA"/>
@@ -9913,7 +9927,7 @@
                     <a:bodyPr/>
                     <a:lstStyle/>
                     <a:p>
-                      <a:pPr indent="0" marL="0">
+                      <a:pPr marL="0" indent="0">
                         <a:buNone/>
                       </a:pPr>
                       <a:r>
@@ -9934,7 +9948,7 @@
                       </a:endParaRPr>
                     </a:p>
                   </a:txBody>
-                  <a:tcPr marL="91440" marR="91440" marT="45720" marB="45720" anchor="ctr">
+                  <a:tcPr anchor="ctr">
                     <a:lnL w="6350" cap="flat" cmpd="sng" algn="ctr">
                       <a:solidFill>
                         <a:srgbClr val="DDDFEA"/>
@@ -9973,6 +9987,11 @@
                     </a:lnB>
                   </a:tcPr>
                 </a:tc>
+                <a:extLst>
+                  <a:ext uri="{0D108BD9-81ED-4DB2-BD59-A6C34878D82A}">
+                    <a16:rowId xmlns:a16="http://schemas.microsoft.com/office/drawing/2014/main" val="10004"/>
+                  </a:ext>
+                </a:extLst>
               </a:tr>
               <a:tr h="342900">
                 <a:tc>
@@ -9980,7 +9999,7 @@
                     <a:bodyPr/>
                     <a:lstStyle/>
                     <a:p>
-                      <a:pPr indent="0" marL="0">
+                      <a:pPr marL="0" indent="0">
                         <a:buNone/>
                       </a:pPr>
                       <a:r>
@@ -10001,7 +10020,7 @@
                       </a:endParaRPr>
                     </a:p>
                   </a:txBody>
-                  <a:tcPr marL="91440" marR="91440" marT="45720" marB="45720" anchor="ctr">
+                  <a:tcPr anchor="ctr">
                     <a:lnL w="6350" cap="flat" cmpd="sng" algn="ctr">
                       <a:solidFill>
                         <a:srgbClr val="DDDFEA"/>
@@ -10045,7 +10064,7 @@
                     <a:bodyPr/>
                     <a:lstStyle/>
                     <a:p>
-                      <a:pPr algn="ctr" indent="0" marL="0">
+                      <a:pPr marL="0" indent="0" algn="ctr">
                         <a:buNone/>
                       </a:pPr>
                       <a:r>
@@ -10066,7 +10085,7 @@
                       </a:endParaRPr>
                     </a:p>
                   </a:txBody>
-                  <a:tcPr marL="91440" marR="91440" marT="45720" marB="45720" anchor="ctr">
+                  <a:tcPr anchor="ctr">
                     <a:lnL w="6350" cap="flat" cmpd="sng" algn="ctr">
                       <a:solidFill>
                         <a:srgbClr val="DDDFEA"/>
@@ -10110,7 +10129,7 @@
                     <a:bodyPr/>
                     <a:lstStyle/>
                     <a:p>
-                      <a:pPr indent="0" marL="0">
+                      <a:pPr marL="0" indent="0">
                         <a:buNone/>
                       </a:pPr>
                       <a:r>
@@ -10131,7 +10150,7 @@
                       </a:endParaRPr>
                     </a:p>
                   </a:txBody>
-                  <a:tcPr marL="91440" marR="91440" marT="45720" marB="45720" anchor="ctr">
+                  <a:tcPr anchor="ctr">
                     <a:lnL w="6350" cap="flat" cmpd="sng" algn="ctr">
                       <a:solidFill>
                         <a:srgbClr val="DDDFEA"/>
@@ -10170,6 +10189,11 @@
                     </a:lnB>
                   </a:tcPr>
                 </a:tc>
+                <a:extLst>
+                  <a:ext uri="{0D108BD9-81ED-4DB2-BD59-A6C34878D82A}">
+                    <a16:rowId xmlns:a16="http://schemas.microsoft.com/office/drawing/2014/main" val="10005"/>
+                  </a:ext>
+                </a:extLst>
               </a:tr>
               <a:tr h="342900">
                 <a:tc>
@@ -10177,7 +10201,7 @@
                     <a:bodyPr/>
                     <a:lstStyle/>
                     <a:p>
-                      <a:pPr indent="0" marL="0">
+                      <a:pPr marL="0" indent="0">
                         <a:buNone/>
                       </a:pPr>
                       <a:r>
@@ -10198,7 +10222,7 @@
                       </a:endParaRPr>
                     </a:p>
                   </a:txBody>
-                  <a:tcPr marL="91440" marR="91440" marT="45720" marB="45720" anchor="ctr">
+                  <a:tcPr anchor="ctr">
                     <a:lnL w="6350" cap="flat" cmpd="sng" algn="ctr">
                       <a:solidFill>
                         <a:srgbClr val="DDDFEA"/>
@@ -10242,7 +10266,7 @@
                     <a:bodyPr/>
                     <a:lstStyle/>
                     <a:p>
-                      <a:pPr algn="ctr" indent="0" marL="0">
+                      <a:pPr marL="0" indent="0" algn="ctr">
                         <a:buNone/>
                       </a:pPr>
                       <a:r>
@@ -10263,7 +10287,7 @@
                       </a:endParaRPr>
                     </a:p>
                   </a:txBody>
-                  <a:tcPr marL="91440" marR="91440" marT="45720" marB="45720" anchor="ctr">
+                  <a:tcPr anchor="ctr">
                     <a:lnL w="6350" cap="flat" cmpd="sng" algn="ctr">
                       <a:solidFill>
                         <a:srgbClr val="DDDFEA"/>
@@ -10307,7 +10331,7 @@
                     <a:bodyPr/>
                     <a:lstStyle/>
                     <a:p>
-                      <a:pPr indent="0" marL="0">
+                      <a:pPr marL="0" indent="0">
                         <a:buNone/>
                       </a:pPr>
                       <a:r>
@@ -10328,7 +10352,7 @@
                       </a:endParaRPr>
                     </a:p>
                   </a:txBody>
-                  <a:tcPr marL="91440" marR="91440" marT="45720" marB="45720" anchor="ctr">
+                  <a:tcPr anchor="ctr">
                     <a:lnL w="6350" cap="flat" cmpd="sng" algn="ctr">
                       <a:solidFill>
                         <a:srgbClr val="DDDFEA"/>
@@ -10367,6 +10391,11 @@
                     </a:lnB>
                   </a:tcPr>
                 </a:tc>
+                <a:extLst>
+                  <a:ext uri="{0D108BD9-81ED-4DB2-BD59-A6C34878D82A}">
+                    <a16:rowId xmlns:a16="http://schemas.microsoft.com/office/drawing/2014/main" val="10006"/>
+                  </a:ext>
+                </a:extLst>
               </a:tr>
               <a:tr h="342900">
                 <a:tc>
@@ -10374,7 +10403,7 @@
                     <a:bodyPr/>
                     <a:lstStyle/>
                     <a:p>
-                      <a:pPr indent="0" marL="0">
+                      <a:pPr marL="0" indent="0">
                         <a:buNone/>
                       </a:pPr>
                       <a:r>
@@ -10395,7 +10424,7 @@
                       </a:endParaRPr>
                     </a:p>
                   </a:txBody>
-                  <a:tcPr marL="91440" marR="91440" marT="45720" marB="45720" anchor="ctr">
+                  <a:tcPr anchor="ctr">
                     <a:lnL w="6350" cap="flat" cmpd="sng" algn="ctr">
                       <a:solidFill>
                         <a:srgbClr val="DDDFEA"/>
@@ -10439,7 +10468,7 @@
                     <a:bodyPr/>
                     <a:lstStyle/>
                     <a:p>
-                      <a:pPr algn="ctr" indent="0" marL="0">
+                      <a:pPr marL="0" indent="0" algn="ctr">
                         <a:buNone/>
                       </a:pPr>
                       <a:r>
@@ -10460,7 +10489,7 @@
                       </a:endParaRPr>
                     </a:p>
                   </a:txBody>
-                  <a:tcPr marL="91440" marR="91440" marT="45720" marB="45720" anchor="ctr">
+                  <a:tcPr anchor="ctr">
                     <a:lnL w="6350" cap="flat" cmpd="sng" algn="ctr">
                       <a:solidFill>
                         <a:srgbClr val="DDDFEA"/>
@@ -10504,7 +10533,7 @@
                     <a:bodyPr/>
                     <a:lstStyle/>
                     <a:p>
-                      <a:pPr indent="0" marL="0">
+                      <a:pPr marL="0" indent="0">
                         <a:buNone/>
                       </a:pPr>
                       <a:r>
@@ -10525,7 +10554,7 @@
                       </a:endParaRPr>
                     </a:p>
                   </a:txBody>
-                  <a:tcPr marL="91440" marR="91440" marT="45720" marB="45720" anchor="ctr">
+                  <a:tcPr anchor="ctr">
                     <a:lnL w="6350" cap="flat" cmpd="sng" algn="ctr">
                       <a:solidFill>
                         <a:srgbClr val="DDDFEA"/>
@@ -10564,6 +10593,11 @@
                     </a:lnB>
                   </a:tcPr>
                 </a:tc>
+                <a:extLst>
+                  <a:ext uri="{0D108BD9-81ED-4DB2-BD59-A6C34878D82A}">
+                    <a16:rowId xmlns:a16="http://schemas.microsoft.com/office/drawing/2014/main" val="10007"/>
+                  </a:ext>
+                </a:extLst>
               </a:tr>
               <a:tr h="342900">
                 <a:tc>
@@ -10571,7 +10605,7 @@
                     <a:bodyPr/>
                     <a:lstStyle/>
                     <a:p>
-                      <a:pPr indent="0" marL="0">
+                      <a:pPr marL="0" indent="0">
                         <a:buNone/>
                       </a:pPr>
                       <a:r>
@@ -10592,7 +10626,7 @@
                       </a:endParaRPr>
                     </a:p>
                   </a:txBody>
-                  <a:tcPr marL="91440" marR="91440" marT="45720" marB="45720" anchor="ctr">
+                  <a:tcPr anchor="ctr">
                     <a:lnL w="6350" cap="flat" cmpd="sng" algn="ctr">
                       <a:solidFill>
                         <a:srgbClr val="DDDFEA"/>
@@ -10636,7 +10670,7 @@
                     <a:bodyPr/>
                     <a:lstStyle/>
                     <a:p>
-                      <a:pPr algn="ctr" indent="0" marL="0">
+                      <a:pPr marL="0" indent="0" algn="ctr">
                         <a:buNone/>
                       </a:pPr>
                       <a:r>
@@ -10657,7 +10691,7 @@
                       </a:endParaRPr>
                     </a:p>
                   </a:txBody>
-                  <a:tcPr marL="91440" marR="91440" marT="45720" marB="45720" anchor="ctr">
+                  <a:tcPr anchor="ctr">
                     <a:lnL w="6350" cap="flat" cmpd="sng" algn="ctr">
                       <a:solidFill>
                         <a:srgbClr val="DDDFEA"/>
@@ -10701,7 +10735,7 @@
                     <a:bodyPr/>
                     <a:lstStyle/>
                     <a:p>
-                      <a:pPr indent="0" marL="0">
+                      <a:pPr marL="0" indent="0">
                         <a:buNone/>
                       </a:pPr>
                       <a:r>
@@ -10722,7 +10756,7 @@
                       </a:endParaRPr>
                     </a:p>
                   </a:txBody>
-                  <a:tcPr marL="91440" marR="91440" marT="45720" marB="45720" anchor="ctr">
+                  <a:tcPr anchor="ctr">
                     <a:lnL w="6350" cap="flat" cmpd="sng" algn="ctr">
                       <a:solidFill>
                         <a:srgbClr val="DDDFEA"/>
@@ -10761,6 +10795,11 @@
                     </a:lnB>
                   </a:tcPr>
                 </a:tc>
+                <a:extLst>
+                  <a:ext uri="{0D108BD9-81ED-4DB2-BD59-A6C34878D82A}">
+                    <a16:rowId xmlns:a16="http://schemas.microsoft.com/office/drawing/2014/main" val="10008"/>
+                  </a:ext>
+                </a:extLst>
               </a:tr>
               <a:tr h="342900">
                 <a:tc>
@@ -10768,7 +10807,7 @@
                     <a:bodyPr/>
                     <a:lstStyle/>
                     <a:p>
-                      <a:pPr indent="0" marL="0">
+                      <a:pPr marL="0" indent="0">
                         <a:buNone/>
                       </a:pPr>
                       <a:r>
@@ -10789,7 +10828,7 @@
                       </a:endParaRPr>
                     </a:p>
                   </a:txBody>
-                  <a:tcPr marL="91440" marR="91440" marT="45720" marB="45720" anchor="ctr">
+                  <a:tcPr anchor="ctr">
                     <a:lnL w="6350" cap="flat" cmpd="sng" algn="ctr">
                       <a:solidFill>
                         <a:srgbClr val="DDDFEA"/>
@@ -10833,7 +10872,7 @@
                     <a:bodyPr/>
                     <a:lstStyle/>
                     <a:p>
-                      <a:pPr algn="ctr" indent="0" marL="0">
+                      <a:pPr marL="0" indent="0" algn="ctr">
                         <a:buNone/>
                       </a:pPr>
                       <a:r>
@@ -10854,7 +10893,7 @@
                       </a:endParaRPr>
                     </a:p>
                   </a:txBody>
-                  <a:tcPr marL="91440" marR="91440" marT="45720" marB="45720" anchor="ctr">
+                  <a:tcPr anchor="ctr">
                     <a:lnL w="6350" cap="flat" cmpd="sng" algn="ctr">
                       <a:solidFill>
                         <a:srgbClr val="DDDFEA"/>
@@ -10898,7 +10937,7 @@
                     <a:bodyPr/>
                     <a:lstStyle/>
                     <a:p>
-                      <a:pPr indent="0" marL="0">
+                      <a:pPr marL="0" indent="0">
                         <a:buNone/>
                       </a:pPr>
                       <a:r>
@@ -10919,7 +10958,7 @@
                       </a:endParaRPr>
                     </a:p>
                   </a:txBody>
-                  <a:tcPr marL="91440" marR="91440" marT="45720" marB="45720" anchor="ctr">
+                  <a:tcPr anchor="ctr">
                     <a:lnL w="6350" cap="flat" cmpd="sng" algn="ctr">
                       <a:solidFill>
                         <a:srgbClr val="DDDFEA"/>
@@ -10958,6 +10997,11 @@
                     </a:lnB>
                   </a:tcPr>
                 </a:tc>
+                <a:extLst>
+                  <a:ext uri="{0D108BD9-81ED-4DB2-BD59-A6C34878D82A}">
+                    <a16:rowId xmlns:a16="http://schemas.microsoft.com/office/drawing/2014/main" val="10009"/>
+                  </a:ext>
+                </a:extLst>
               </a:tr>
             </a:tbl>
           </a:graphicData>
@@ -11264,4 +11308,319 @@
     </a:ext>
   </a:extLst>
 </a:theme>
+</file>
+
+<file path=ppt/theme/theme2.xml><?xml version="1.0" encoding="utf-8"?>
+<a:theme xmlns:a="http://schemas.openxmlformats.org/drawingml/2006/main" name="Office Theme">
+  <a:themeElements>
+    <a:clrScheme name="Office">
+      <a:dk1>
+        <a:sysClr val="windowText" lastClr="000000"/>
+      </a:dk1>
+      <a:lt1>
+        <a:sysClr val="window" lastClr="FFFFFF"/>
+      </a:lt1>
+      <a:dk2>
+        <a:srgbClr val="0E2841"/>
+      </a:dk2>
+      <a:lt2>
+        <a:srgbClr val="E8E8E8"/>
+      </a:lt2>
+      <a:accent1>
+        <a:srgbClr val="156082"/>
+      </a:accent1>
+      <a:accent2>
+        <a:srgbClr val="E97132"/>
+      </a:accent2>
+      <a:accent3>
+        <a:srgbClr val="196B24"/>
+      </a:accent3>
+      <a:accent4>
+        <a:srgbClr val="0F9ED5"/>
+      </a:accent4>
+      <a:accent5>
+        <a:srgbClr val="A02B93"/>
+      </a:accent5>
+      <a:accent6>
+        <a:srgbClr val="4EA72E"/>
+      </a:accent6>
+      <a:hlink>
+        <a:srgbClr val="467886"/>
+      </a:hlink>
+      <a:folHlink>
+        <a:srgbClr val="96607D"/>
+      </a:folHlink>
+    </a:clrScheme>
+    <a:fontScheme name="Office">
+      <a:majorFont>
+        <a:latin typeface="Aptos Display" panose="02110004020202020204"/>
+        <a:ea typeface=""/>
+        <a:cs typeface=""/>
+        <a:font script="Jpan" typeface="游ゴシック Light"/>
+        <a:font script="Hang" typeface="맑은 고딕"/>
+        <a:font script="Hans" typeface="等线 Light"/>
+        <a:font script="Hant" typeface="新細明體"/>
+        <a:font script="Arab" typeface="Times New Roman"/>
+        <a:font script="Hebr" typeface="Times New Roman"/>
+        <a:font script="Thai" typeface="Angsana New"/>
+        <a:font script="Ethi" typeface="Nyala"/>
+        <a:font script="Beng" typeface="Vrinda"/>
+        <a:font script="Gujr" typeface="Shruti"/>
+        <a:font script="Khmr" typeface="MoolBoran"/>
+        <a:font script="Knda" typeface="Tunga"/>
+        <a:font script="Guru" typeface="Raavi"/>
+        <a:font script="Cans" typeface="Euphemia"/>
+        <a:font script="Cher" typeface="Plantagenet Cherokee"/>
+        <a:font script="Yiii" typeface="Microsoft Yi Baiti"/>
+        <a:font script="Tibt" typeface="Microsoft Himalaya"/>
+        <a:font script="Thaa" typeface="MV Boli"/>
+        <a:font script="Deva" typeface="Mangal"/>
+        <a:font script="Telu" typeface="Gautami"/>
+        <a:font script="Taml" typeface="Latha"/>
+        <a:font script="Syrc" typeface="Estrangelo Edessa"/>
+        <a:font script="Orya" typeface="Kalinga"/>
+        <a:font script="Mlym" typeface="Kartika"/>
+        <a:font script="Laoo" typeface="DokChampa"/>
+        <a:font script="Sinh" typeface="Iskoola Pota"/>
+        <a:font script="Mong" typeface="Mongolian Baiti"/>
+        <a:font script="Viet" typeface="Times New Roman"/>
+        <a:font script="Uigh" typeface="Microsoft Uighur"/>
+        <a:font script="Geor" typeface="Sylfaen"/>
+        <a:font script="Armn" typeface="Arial"/>
+        <a:font script="Bugi" typeface="Leelawadee UI"/>
+        <a:font script="Bopo" typeface="Microsoft JhengHei"/>
+        <a:font script="Java" typeface="Javanese Text"/>
+        <a:font script="Lisu" typeface="Segoe UI"/>
+        <a:font script="Mymr" typeface="Myanmar Text"/>
+        <a:font script="Nkoo" typeface="Ebrima"/>
+        <a:font script="Olck" typeface="Nirmala UI"/>
+        <a:font script="Osma" typeface="Ebrima"/>
+        <a:font script="Phag" typeface="Phagspa"/>
+        <a:font script="Syrn" typeface="Estrangelo Edessa"/>
+        <a:font script="Syrj" typeface="Estrangelo Edessa"/>
+        <a:font script="Syre" typeface="Estrangelo Edessa"/>
+        <a:font script="Sora" typeface="Nirmala UI"/>
+        <a:font script="Tale" typeface="Microsoft Tai Le"/>
+        <a:font script="Talu" typeface="Microsoft New Tai Lue"/>
+        <a:font script="Tfng" typeface="Ebrima"/>
+      </a:majorFont>
+      <a:minorFont>
+        <a:latin typeface="Aptos" panose="02110004020202020204"/>
+        <a:ea typeface=""/>
+        <a:cs typeface=""/>
+        <a:font script="Jpan" typeface="游ゴシック"/>
+        <a:font script="Hang" typeface="맑은 고딕"/>
+        <a:font script="Hans" typeface="等线"/>
+        <a:font script="Hant" typeface="新細明體"/>
+        <a:font script="Arab" typeface="Arial"/>
+        <a:font script="Hebr" typeface="Arial"/>
+        <a:font script="Thai" typeface="Cordia New"/>
+        <a:font script="Ethi" typeface="Nyala"/>
+        <a:font script="Beng" typeface="Vrinda"/>
+        <a:font script="Gujr" typeface="Shruti"/>
+        <a:font script="Khmr" typeface="DaunPenh"/>
+        <a:font script="Knda" typeface="Tunga"/>
+        <a:font script="Guru" typeface="Raavi"/>
+        <a:font script="Cans" typeface="Euphemia"/>
+        <a:font script="Cher" typeface="Plantagenet Cherokee"/>
+        <a:font script="Yiii" typeface="Microsoft Yi Baiti"/>
+        <a:font script="Tibt" typeface="Microsoft Himalaya"/>
+        <a:font script="Thaa" typeface="MV Boli"/>
+        <a:font script="Deva" typeface="Mangal"/>
+        <a:font script="Telu" typeface="Gautami"/>
+        <a:font script="Taml" typeface="Latha"/>
+        <a:font script="Syrc" typeface="Estrangelo Edessa"/>
+        <a:font script="Orya" typeface="Kalinga"/>
+        <a:font script="Mlym" typeface="Kartika"/>
+        <a:font script="Laoo" typeface="DokChampa"/>
+        <a:font script="Sinh" typeface="Iskoola Pota"/>
+        <a:font script="Mong" typeface="Mongolian Baiti"/>
+        <a:font script="Viet" typeface="Arial"/>
+        <a:font script="Uigh" typeface="Microsoft Uighur"/>
+        <a:font script="Geor" typeface="Sylfaen"/>
+        <a:font script="Armn" typeface="Arial"/>
+        <a:font script="Bugi" typeface="Leelawadee UI"/>
+        <a:font script="Bopo" typeface="Microsoft JhengHei"/>
+        <a:font script="Java" typeface="Javanese Text"/>
+        <a:font script="Lisu" typeface="Segoe UI"/>
+        <a:font script="Mymr" typeface="Myanmar Text"/>
+        <a:font script="Nkoo" typeface="Ebrima"/>
+        <a:font script="Olck" typeface="Nirmala UI"/>
+        <a:font script="Osma" typeface="Ebrima"/>
+        <a:font script="Phag" typeface="Phagspa"/>
+        <a:font script="Syrn" typeface="Estrangelo Edessa"/>
+        <a:font script="Syrj" typeface="Estrangelo Edessa"/>
+        <a:font script="Syre" typeface="Estrangelo Edessa"/>
+        <a:font script="Sora" typeface="Nirmala UI"/>
+        <a:font script="Tale" typeface="Microsoft Tai Le"/>
+        <a:font script="Talu" typeface="Microsoft New Tai Lue"/>
+        <a:font script="Tfng" typeface="Ebrima"/>
+      </a:minorFont>
+    </a:fontScheme>
+    <a:fmtScheme name="Office">
+      <a:fillStyleLst>
+        <a:solidFill>
+          <a:schemeClr val="phClr"/>
+        </a:solidFill>
+        <a:gradFill rotWithShape="1">
+          <a:gsLst>
+            <a:gs pos="0">
+              <a:schemeClr val="phClr">
+                <a:lumMod val="110000"/>
+                <a:satMod val="105000"/>
+                <a:tint val="67000"/>
+              </a:schemeClr>
+            </a:gs>
+            <a:gs pos="50000">
+              <a:schemeClr val="phClr">
+                <a:lumMod val="105000"/>
+                <a:satMod val="103000"/>
+                <a:tint val="73000"/>
+              </a:schemeClr>
+            </a:gs>
+            <a:gs pos="100000">
+              <a:schemeClr val="phClr">
+                <a:lumMod val="105000"/>
+                <a:satMod val="109000"/>
+                <a:tint val="81000"/>
+              </a:schemeClr>
+            </a:gs>
+          </a:gsLst>
+          <a:lin ang="5400000" scaled="0"/>
+        </a:gradFill>
+        <a:gradFill rotWithShape="1">
+          <a:gsLst>
+            <a:gs pos="0">
+              <a:schemeClr val="phClr">
+                <a:satMod val="103000"/>
+                <a:lumMod val="102000"/>
+                <a:tint val="94000"/>
+              </a:schemeClr>
+            </a:gs>
+            <a:gs pos="50000">
+              <a:schemeClr val="phClr">
+                <a:satMod val="110000"/>
+                <a:lumMod val="100000"/>
+                <a:shade val="100000"/>
+              </a:schemeClr>
+            </a:gs>
+            <a:gs pos="100000">
+              <a:schemeClr val="phClr">
+                <a:lumMod val="99000"/>
+                <a:satMod val="120000"/>
+                <a:shade val="78000"/>
+              </a:schemeClr>
+            </a:gs>
+          </a:gsLst>
+          <a:lin ang="5400000" scaled="0"/>
+        </a:gradFill>
+      </a:fillStyleLst>
+      <a:lnStyleLst>
+        <a:ln w="12700" cap="flat" cmpd="sng" algn="ctr">
+          <a:solidFill>
+            <a:schemeClr val="phClr"/>
+          </a:solidFill>
+          <a:prstDash val="solid"/>
+          <a:miter lim="800000"/>
+        </a:ln>
+        <a:ln w="19050" cap="flat" cmpd="sng" algn="ctr">
+          <a:solidFill>
+            <a:schemeClr val="phClr"/>
+          </a:solidFill>
+          <a:prstDash val="solid"/>
+          <a:miter lim="800000"/>
+        </a:ln>
+        <a:ln w="25400" cap="flat" cmpd="sng" algn="ctr">
+          <a:solidFill>
+            <a:schemeClr val="phClr"/>
+          </a:solidFill>
+          <a:prstDash val="solid"/>
+          <a:miter lim="800000"/>
+        </a:ln>
+      </a:lnStyleLst>
+      <a:effectStyleLst>
+        <a:effectStyle>
+          <a:effectLst/>
+        </a:effectStyle>
+        <a:effectStyle>
+          <a:effectLst/>
+        </a:effectStyle>
+        <a:effectStyle>
+          <a:effectLst>
+            <a:outerShdw blurRad="57150" dist="19050" dir="5400000" algn="ctr" rotWithShape="0">
+              <a:srgbClr val="000000">
+                <a:alpha val="63000"/>
+              </a:srgbClr>
+            </a:outerShdw>
+          </a:effectLst>
+        </a:effectStyle>
+      </a:effectStyleLst>
+      <a:bgFillStyleLst>
+        <a:solidFill>
+          <a:schemeClr val="phClr"/>
+        </a:solidFill>
+        <a:solidFill>
+          <a:schemeClr val="phClr">
+            <a:tint val="95000"/>
+            <a:satMod val="170000"/>
+          </a:schemeClr>
+        </a:solidFill>
+        <a:gradFill rotWithShape="1">
+          <a:gsLst>
+            <a:gs pos="0">
+              <a:schemeClr val="phClr">
+                <a:tint val="93000"/>
+                <a:satMod val="150000"/>
+                <a:shade val="98000"/>
+                <a:lumMod val="102000"/>
+              </a:schemeClr>
+            </a:gs>
+            <a:gs pos="50000">
+              <a:schemeClr val="phClr">
+                <a:tint val="98000"/>
+                <a:satMod val="130000"/>
+                <a:shade val="90000"/>
+                <a:lumMod val="103000"/>
+              </a:schemeClr>
+            </a:gs>
+            <a:gs pos="100000">
+              <a:schemeClr val="phClr">
+                <a:shade val="63000"/>
+                <a:satMod val="120000"/>
+              </a:schemeClr>
+            </a:gs>
+          </a:gsLst>
+          <a:lin ang="5400000" scaled="0"/>
+        </a:gradFill>
+      </a:bgFillStyleLst>
+    </a:fmtScheme>
+  </a:themeElements>
+  <a:objectDefaults>
+    <a:lnDef>
+      <a:spPr/>
+      <a:bodyPr/>
+      <a:lstStyle/>
+      <a:style>
+        <a:lnRef idx="2">
+          <a:schemeClr val="accent1"/>
+        </a:lnRef>
+        <a:fillRef idx="0">
+          <a:schemeClr val="accent1"/>
+        </a:fillRef>
+        <a:effectRef idx="1">
+          <a:schemeClr val="accent1"/>
+        </a:effectRef>
+        <a:fontRef idx="minor">
+          <a:schemeClr val="tx1"/>
+        </a:fontRef>
+      </a:style>
+    </a:lnDef>
+  </a:objectDefaults>
+  <a:extraClrSchemeLst/>
+  <a:extLst>
+    <a:ext uri="{05A4C25C-085E-4340-85A3-A5531E510DB2}">
+      <thm15:themeFamily xmlns:thm15="http://schemas.microsoft.com/office/thememl/2012/main" name="Office Theme" id="{2E142A2C-CD16-42D6-873A-C26D2A0506FA}" vid="{1BDDFF52-6CD6-40A5-AB3C-68EB2F1E4D0A}"/>
+    </a:ext>
+  </a:extLst>
+</a:theme>
 </file>
</xml_diff>

<commit_message>
Added npm audit report
</commit_message>
<xml_diff>
--- a/presentation/MoodStreak.pptx
+++ b/presentation/MoodStreak.pptx
@@ -5,7 +5,7 @@
     <p:sldMasterId id="2147483648" r:id="rId1"/>
   </p:sldMasterIdLst>
   <p:notesMasterIdLst>
-    <p:notesMasterId r:id="rId12"/>
+    <p:notesMasterId r:id="rId14"/>
   </p:notesMasterIdLst>
   <p:sldIdLst>
     <p:sldId id="256" r:id="rId2"/>
@@ -17,7 +17,9 @@
     <p:sldId id="262" r:id="rId8"/>
     <p:sldId id="263" r:id="rId9"/>
     <p:sldId id="264" r:id="rId10"/>
-    <p:sldId id="265" r:id="rId11"/>
+    <p:sldId id="266" r:id="rId11"/>
+    <p:sldId id="267" r:id="rId12"/>
+    <p:sldId id="265" r:id="rId13"/>
   </p:sldIdLst>
   <p:sldSz cx="9144000" cy="5143500" type="screen16x9"/>
   <p:notesSz cx="5143500" cy="9144000"/>
@@ -335,6 +337,222 @@
   <p:cSld>
     <p:spTree>
       <p:nvGrpSpPr>
+        <p:cNvPr id="1" name="">
+          <a:extLst>
+            <a:ext uri="{FF2B5EF4-FFF2-40B4-BE49-F238E27FC236}">
+              <a16:creationId xmlns:a16="http://schemas.microsoft.com/office/drawing/2014/main" id="{E116CD03-CDF8-B896-4DCC-3C7FF7CF8B35}"/>
+            </a:ext>
+          </a:extLst>
+        </p:cNvPr>
+        <p:cNvGrpSpPr/>
+        <p:nvPr/>
+      </p:nvGrpSpPr>
+      <p:grpSpPr>
+        <a:xfrm>
+          <a:off x="0" y="0"/>
+          <a:ext cx="0" cy="0"/>
+          <a:chOff x="0" y="0"/>
+          <a:chExt cx="0" cy="0"/>
+        </a:xfrm>
+      </p:grpSpPr>
+      <p:sp>
+        <p:nvSpPr>
+          <p:cNvPr id="2" name="Slide Image Placeholder 1">
+            <a:extLst>
+              <a:ext uri="{FF2B5EF4-FFF2-40B4-BE49-F238E27FC236}">
+                <a16:creationId xmlns:a16="http://schemas.microsoft.com/office/drawing/2014/main" id="{5F190565-EEE2-9BE1-7B4E-9BAEC92FC291}"/>
+              </a:ext>
+            </a:extLst>
+          </p:cNvPr>
+          <p:cNvSpPr>
+            <a:spLocks noGrp="1" noRot="1" noChangeAspect="1"/>
+          </p:cNvSpPr>
+          <p:nvPr>
+            <p:ph type="sldImg"/>
+          </p:nvPr>
+        </p:nvSpPr>
+        <p:spPr/>
+      </p:sp>
+      <p:sp>
+        <p:nvSpPr>
+          <p:cNvPr id="3" name="Notes Placeholder 2">
+            <a:extLst>
+              <a:ext uri="{FF2B5EF4-FFF2-40B4-BE49-F238E27FC236}">
+                <a16:creationId xmlns:a16="http://schemas.microsoft.com/office/drawing/2014/main" id="{08DAABED-1436-B890-965E-16DB92BB2CF3}"/>
+              </a:ext>
+            </a:extLst>
+          </p:cNvPr>
+          <p:cNvSpPr>
+            <a:spLocks noGrp="1"/>
+          </p:cNvSpPr>
+          <p:nvPr>
+            <p:ph type="body" idx="1"/>
+          </p:nvPr>
+        </p:nvSpPr>
+        <p:spPr/>
+        <p:txBody>
+          <a:bodyPr/>
+          <a:lstStyle/>
+          <a:p>
+            <a:endParaRPr lang="en-US" dirty="0"/>
+          </a:p>
+        </p:txBody>
+      </p:sp>
+      <p:sp>
+        <p:nvSpPr>
+          <p:cNvPr id="4" name="Slide Number Placeholder 3">
+            <a:extLst>
+              <a:ext uri="{FF2B5EF4-FFF2-40B4-BE49-F238E27FC236}">
+                <a16:creationId xmlns:a16="http://schemas.microsoft.com/office/drawing/2014/main" id="{6BEB5EB6-F824-EBF6-11B2-EB6E5FB6D953}"/>
+              </a:ext>
+            </a:extLst>
+          </p:cNvPr>
+          <p:cNvSpPr>
+            <a:spLocks noGrp="1"/>
+          </p:cNvSpPr>
+          <p:nvPr>
+            <p:ph type="sldNum" sz="quarter" idx="10"/>
+          </p:nvPr>
+        </p:nvSpPr>
+        <p:spPr/>
+        <p:txBody>
+          <a:bodyPr/>
+          <a:lstStyle/>
+          <a:p>
+            <a:fld id="{F7021451-1387-4CA6-816F-3879F97B5CBC}" type="slidenum">
+              <a:rPr lang="en-US"/>
+              <a:t>10</a:t>
+            </a:fld>
+            <a:endParaRPr lang="en-US"/>
+          </a:p>
+        </p:txBody>
+      </p:sp>
+    </p:spTree>
+    <p:extLst>
+      <p:ext uri="{BB962C8B-B14F-4D97-AF65-F5344CB8AC3E}">
+        <p14:creationId xmlns:p14="http://schemas.microsoft.com/office/powerpoint/2010/main" val="3402032641"/>
+      </p:ext>
+    </p:extLst>
+  </p:cSld>
+  <p:clrMapOvr>
+    <a:masterClrMapping/>
+  </p:clrMapOvr>
+</p:notes>
+</file>
+
+<file path=ppt/notesSlides/notesSlide11.xml><?xml version="1.0" encoding="utf-8"?>
+<p:notes xmlns:a="http://schemas.openxmlformats.org/drawingml/2006/main" xmlns:r="http://schemas.openxmlformats.org/officeDocument/2006/relationships" xmlns:p="http://schemas.openxmlformats.org/presentationml/2006/main">
+  <p:cSld>
+    <p:spTree>
+      <p:nvGrpSpPr>
+        <p:cNvPr id="1" name="">
+          <a:extLst>
+            <a:ext uri="{FF2B5EF4-FFF2-40B4-BE49-F238E27FC236}">
+              <a16:creationId xmlns:a16="http://schemas.microsoft.com/office/drawing/2014/main" id="{61599FBB-0EA0-5656-E200-BE21684D0498}"/>
+            </a:ext>
+          </a:extLst>
+        </p:cNvPr>
+        <p:cNvGrpSpPr/>
+        <p:nvPr/>
+      </p:nvGrpSpPr>
+      <p:grpSpPr>
+        <a:xfrm>
+          <a:off x="0" y="0"/>
+          <a:ext cx="0" cy="0"/>
+          <a:chOff x="0" y="0"/>
+          <a:chExt cx="0" cy="0"/>
+        </a:xfrm>
+      </p:grpSpPr>
+      <p:sp>
+        <p:nvSpPr>
+          <p:cNvPr id="2" name="Slide Image Placeholder 1">
+            <a:extLst>
+              <a:ext uri="{FF2B5EF4-FFF2-40B4-BE49-F238E27FC236}">
+                <a16:creationId xmlns:a16="http://schemas.microsoft.com/office/drawing/2014/main" id="{8F240E0A-EBC1-070A-0521-796B73A9D549}"/>
+              </a:ext>
+            </a:extLst>
+          </p:cNvPr>
+          <p:cNvSpPr>
+            <a:spLocks noGrp="1" noRot="1" noChangeAspect="1"/>
+          </p:cNvSpPr>
+          <p:nvPr>
+            <p:ph type="sldImg"/>
+          </p:nvPr>
+        </p:nvSpPr>
+        <p:spPr/>
+      </p:sp>
+      <p:sp>
+        <p:nvSpPr>
+          <p:cNvPr id="3" name="Notes Placeholder 2">
+            <a:extLst>
+              <a:ext uri="{FF2B5EF4-FFF2-40B4-BE49-F238E27FC236}">
+                <a16:creationId xmlns:a16="http://schemas.microsoft.com/office/drawing/2014/main" id="{85A1840D-A1CE-C838-A911-0C01765F6F13}"/>
+              </a:ext>
+            </a:extLst>
+          </p:cNvPr>
+          <p:cNvSpPr>
+            <a:spLocks noGrp="1"/>
+          </p:cNvSpPr>
+          <p:nvPr>
+            <p:ph type="body" idx="1"/>
+          </p:nvPr>
+        </p:nvSpPr>
+        <p:spPr/>
+        <p:txBody>
+          <a:bodyPr/>
+          <a:lstStyle/>
+          <a:p>
+            <a:endParaRPr lang="en-US" dirty="0"/>
+          </a:p>
+        </p:txBody>
+      </p:sp>
+      <p:sp>
+        <p:nvSpPr>
+          <p:cNvPr id="4" name="Slide Number Placeholder 3">
+            <a:extLst>
+              <a:ext uri="{FF2B5EF4-FFF2-40B4-BE49-F238E27FC236}">
+                <a16:creationId xmlns:a16="http://schemas.microsoft.com/office/drawing/2014/main" id="{65D21769-797B-1F71-A79A-E99168AA039A}"/>
+              </a:ext>
+            </a:extLst>
+          </p:cNvPr>
+          <p:cNvSpPr>
+            <a:spLocks noGrp="1"/>
+          </p:cNvSpPr>
+          <p:nvPr>
+            <p:ph type="sldNum" sz="quarter" idx="10"/>
+          </p:nvPr>
+        </p:nvSpPr>
+        <p:spPr/>
+        <p:txBody>
+          <a:bodyPr/>
+          <a:lstStyle/>
+          <a:p>
+            <a:fld id="{F7021451-1387-4CA6-816F-3879F97B5CBC}" type="slidenum">
+              <a:rPr lang="en-US"/>
+              <a:t>11</a:t>
+            </a:fld>
+            <a:endParaRPr lang="en-US"/>
+          </a:p>
+        </p:txBody>
+      </p:sp>
+    </p:spTree>
+    <p:extLst>
+      <p:ext uri="{BB962C8B-B14F-4D97-AF65-F5344CB8AC3E}">
+        <p14:creationId xmlns:p14="http://schemas.microsoft.com/office/powerpoint/2010/main" val="2024206422"/>
+      </p:ext>
+    </p:extLst>
+  </p:cSld>
+  <p:clrMapOvr>
+    <a:masterClrMapping/>
+  </p:clrMapOvr>
+</p:notes>
+</file>
+
+<file path=ppt/notesSlides/notesSlide12.xml><?xml version="1.0" encoding="utf-8"?>
+<p:notes xmlns:a="http://schemas.openxmlformats.org/drawingml/2006/main" xmlns:r="http://schemas.openxmlformats.org/officeDocument/2006/relationships" xmlns:p="http://schemas.openxmlformats.org/presentationml/2006/main">
+  <p:cSld>
+    <p:spTree>
+      <p:nvGrpSpPr>
         <p:cNvPr id="1" name=""/>
         <p:cNvGrpSpPr/>
         <p:nvPr/>
@@ -395,7 +613,7 @@
           <a:p>
             <a:fld id="{F7021451-1387-4CA6-816F-3879F97B5CBC}" type="slidenum">
               <a:rPr lang="en-US"/>
-              <a:t>10</a:t>
+              <a:t>12</a:t>
             </a:fld>
             <a:endParaRPr lang="en-US"/>
           </a:p>
@@ -1612,6 +1830,485 @@
 </file>
 
 <file path=ppt/slides/slide10.xml><?xml version="1.0" encoding="utf-8"?>
+<p:sld xmlns:a="http://schemas.openxmlformats.org/drawingml/2006/main" xmlns:r="http://schemas.openxmlformats.org/officeDocument/2006/relationships" xmlns:p="http://schemas.openxmlformats.org/presentationml/2006/main">
+  <p:cSld>
+    <p:bg>
+      <p:bgPr>
+        <a:solidFill>
+          <a:srgbClr val="FFFFFF"/>
+        </a:solidFill>
+        <a:effectLst/>
+      </p:bgPr>
+    </p:bg>
+    <p:spTree>
+      <p:nvGrpSpPr>
+        <p:cNvPr id="1" name="">
+          <a:extLst>
+            <a:ext uri="{FF2B5EF4-FFF2-40B4-BE49-F238E27FC236}">
+              <a16:creationId xmlns:a16="http://schemas.microsoft.com/office/drawing/2014/main" id="{A45B00A5-A8B4-8C77-23CC-7ECCBB8BC6A4}"/>
+            </a:ext>
+          </a:extLst>
+        </p:cNvPr>
+        <p:cNvGrpSpPr/>
+        <p:nvPr/>
+      </p:nvGrpSpPr>
+      <p:grpSpPr>
+        <a:xfrm>
+          <a:off x="0" y="0"/>
+          <a:ext cx="0" cy="0"/>
+          <a:chOff x="0" y="0"/>
+          <a:chExt cx="0" cy="0"/>
+        </a:xfrm>
+      </p:grpSpPr>
+      <p:sp>
+        <p:nvSpPr>
+          <p:cNvPr id="2" name="Shape 0">
+            <a:extLst>
+              <a:ext uri="{FF2B5EF4-FFF2-40B4-BE49-F238E27FC236}">
+                <a16:creationId xmlns:a16="http://schemas.microsoft.com/office/drawing/2014/main" id="{D6445B26-61BA-0B57-B1BD-C2C41DF4D486}"/>
+              </a:ext>
+            </a:extLst>
+          </p:cNvPr>
+          <p:cNvSpPr/>
+          <p:nvPr/>
+        </p:nvSpPr>
+        <p:spPr>
+          <a:xfrm>
+            <a:off x="0" y="0"/>
+            <a:ext cx="9144000" cy="109728"/>
+          </a:xfrm>
+          <a:prstGeom prst="rect">
+            <a:avLst/>
+          </a:prstGeom>
+          <a:solidFill>
+            <a:srgbClr val="6C4CF1"/>
+          </a:solidFill>
+          <a:ln w="12700">
+            <a:solidFill>
+              <a:srgbClr val="6C4CF1"/>
+            </a:solidFill>
+            <a:prstDash val="solid"/>
+          </a:ln>
+        </p:spPr>
+        <p:txBody>
+          <a:bodyPr/>
+          <a:lstStyle/>
+          <a:p>
+            <a:endParaRPr lang="en-US"/>
+          </a:p>
+        </p:txBody>
+      </p:sp>
+      <p:sp>
+        <p:nvSpPr>
+          <p:cNvPr id="3" name="Text 1">
+            <a:extLst>
+              <a:ext uri="{FF2B5EF4-FFF2-40B4-BE49-F238E27FC236}">
+                <a16:creationId xmlns:a16="http://schemas.microsoft.com/office/drawing/2014/main" id="{C957A13A-3CB0-08ED-5739-52C637C5F68D}"/>
+              </a:ext>
+            </a:extLst>
+          </p:cNvPr>
+          <p:cNvSpPr/>
+          <p:nvPr/>
+        </p:nvSpPr>
+        <p:spPr>
+          <a:xfrm>
+            <a:off x="457200" y="274320"/>
+            <a:ext cx="8229600" cy="548640"/>
+          </a:xfrm>
+          <a:prstGeom prst="rect">
+            <a:avLst/>
+          </a:prstGeom>
+          <a:noFill/>
+          <a:ln/>
+        </p:spPr>
+        <p:txBody>
+          <a:bodyPr wrap="square" lIns="0" tIns="0" rIns="0" bIns="0" rtlCol="0" anchor="ctr"/>
+          <a:lstStyle/>
+          <a:p>
+            <a:pPr marL="0" indent="0">
+              <a:buNone/>
+            </a:pPr>
+            <a:r>
+              <a:rPr lang="en-US" sz="2800" b="1" dirty="0">
+                <a:solidFill>
+                  <a:srgbClr val="1F2238"/>
+                </a:solidFill>
+                <a:latin typeface="Calibri" pitchFamily="34" charset="0"/>
+                <a:ea typeface="Calibri" pitchFamily="34" charset="-122"/>
+                <a:cs typeface="Calibri" pitchFamily="34" charset="-120"/>
+              </a:rPr>
+              <a:t>Vulnerability analysis (preliminary)</a:t>
+            </a:r>
+            <a:endParaRPr lang="en-US" sz="2800" dirty="0"/>
+          </a:p>
+        </p:txBody>
+      </p:sp>
+      <p:sp>
+        <p:nvSpPr>
+          <p:cNvPr id="4" name="Text 2">
+            <a:extLst>
+              <a:ext uri="{FF2B5EF4-FFF2-40B4-BE49-F238E27FC236}">
+                <a16:creationId xmlns:a16="http://schemas.microsoft.com/office/drawing/2014/main" id="{D5A54336-C664-0EA7-6B03-2863FC067D13}"/>
+              </a:ext>
+            </a:extLst>
+          </p:cNvPr>
+          <p:cNvSpPr/>
+          <p:nvPr/>
+        </p:nvSpPr>
+        <p:spPr>
+          <a:xfrm>
+            <a:off x="457200" y="804672"/>
+            <a:ext cx="8229600" cy="320040"/>
+          </a:xfrm>
+          <a:prstGeom prst="rect">
+            <a:avLst/>
+          </a:prstGeom>
+          <a:noFill/>
+          <a:ln/>
+        </p:spPr>
+        <p:txBody>
+          <a:bodyPr wrap="square" lIns="0" tIns="0" rIns="0" bIns="0" rtlCol="0" anchor="ctr"/>
+          <a:lstStyle/>
+          <a:p>
+            <a:pPr marL="0" indent="0">
+              <a:buNone/>
+            </a:pPr>
+            <a:r>
+              <a:rPr lang="en-US" sz="1400" dirty="0">
+                <a:solidFill>
+                  <a:srgbClr val="6B7088"/>
+                </a:solidFill>
+                <a:latin typeface="Calibri" pitchFamily="34" charset="0"/>
+                <a:ea typeface="Calibri" pitchFamily="34" charset="-122"/>
+                <a:cs typeface="Calibri" pitchFamily="34" charset="-120"/>
+              </a:rPr>
+              <a:t>npm audit + manual probing of the HTTPS API – reported, not yet fixed</a:t>
+            </a:r>
+            <a:endParaRPr lang="en-US" sz="1400" dirty="0"/>
+          </a:p>
+        </p:txBody>
+      </p:sp>
+      <p:pic>
+        <p:nvPicPr>
+          <p:cNvPr id="6" name="Picture 5">
+            <a:extLst>
+              <a:ext uri="{FF2B5EF4-FFF2-40B4-BE49-F238E27FC236}">
+                <a16:creationId xmlns:a16="http://schemas.microsoft.com/office/drawing/2014/main" id="{72688E01-C643-8EC8-BF68-9086975124D3}"/>
+              </a:ext>
+            </a:extLst>
+          </p:cNvPr>
+          <p:cNvPicPr>
+            <a:picLocks noChangeAspect="1"/>
+          </p:cNvPicPr>
+          <p:nvPr/>
+        </p:nvPicPr>
+        <p:blipFill>
+          <a:blip r:embed="rId3"/>
+          <a:stretch>
+            <a:fillRect/>
+          </a:stretch>
+        </p:blipFill>
+        <p:spPr>
+          <a:xfrm>
+            <a:off x="457201" y="1268842"/>
+            <a:ext cx="4922176" cy="2726037"/>
+          </a:xfrm>
+          <a:prstGeom prst="rect">
+            <a:avLst/>
+          </a:prstGeom>
+        </p:spPr>
+      </p:pic>
+      <p:sp>
+        <p:nvSpPr>
+          <p:cNvPr id="7" name="TextBox 6">
+            <a:extLst>
+              <a:ext uri="{FF2B5EF4-FFF2-40B4-BE49-F238E27FC236}">
+                <a16:creationId xmlns:a16="http://schemas.microsoft.com/office/drawing/2014/main" id="{D2A4BEB1-A248-9A3C-A9CB-D04A1A9436CB}"/>
+              </a:ext>
+            </a:extLst>
+          </p:cNvPr>
+          <p:cNvSpPr txBox="1"/>
+          <p:nvPr/>
+        </p:nvSpPr>
+        <p:spPr>
+          <a:xfrm>
+            <a:off x="5543870" y="2156251"/>
+            <a:ext cx="3142929" cy="830997"/>
+          </a:xfrm>
+          <a:prstGeom prst="rect">
+            <a:avLst/>
+          </a:prstGeom>
+          <a:noFill/>
+        </p:spPr>
+        <p:txBody>
+          <a:bodyPr wrap="square" rtlCol="0">
+            <a:spAutoFit/>
+          </a:bodyPr>
+          <a:lstStyle/>
+          <a:p>
+            <a:r>
+              <a:rPr lang="en-US" sz="1600" dirty="0"/>
+              <a:t>0 vulnerabilities in production dependencies; the 3 high findings are dev tooling only.</a:t>
+            </a:r>
+          </a:p>
+        </p:txBody>
+      </p:sp>
+    </p:spTree>
+    <p:extLst>
+      <p:ext uri="{BB962C8B-B14F-4D97-AF65-F5344CB8AC3E}">
+        <p14:creationId xmlns:p14="http://schemas.microsoft.com/office/powerpoint/2010/main" val="1761400550"/>
+      </p:ext>
+    </p:extLst>
+  </p:cSld>
+  <p:clrMapOvr>
+    <a:masterClrMapping/>
+  </p:clrMapOvr>
+</p:sld>
+</file>
+
+<file path=ppt/slides/slide11.xml><?xml version="1.0" encoding="utf-8"?>
+<p:sld xmlns:a="http://schemas.openxmlformats.org/drawingml/2006/main" xmlns:r="http://schemas.openxmlformats.org/officeDocument/2006/relationships" xmlns:p="http://schemas.openxmlformats.org/presentationml/2006/main">
+  <p:cSld>
+    <p:bg>
+      <p:bgPr>
+        <a:solidFill>
+          <a:srgbClr val="FFFFFF"/>
+        </a:solidFill>
+        <a:effectLst/>
+      </p:bgPr>
+    </p:bg>
+    <p:spTree>
+      <p:nvGrpSpPr>
+        <p:cNvPr id="1" name="">
+          <a:extLst>
+            <a:ext uri="{FF2B5EF4-FFF2-40B4-BE49-F238E27FC236}">
+              <a16:creationId xmlns:a16="http://schemas.microsoft.com/office/drawing/2014/main" id="{AC14DA95-04A2-7552-54A0-1B4B62D8B9F8}"/>
+            </a:ext>
+          </a:extLst>
+        </p:cNvPr>
+        <p:cNvGrpSpPr/>
+        <p:nvPr/>
+      </p:nvGrpSpPr>
+      <p:grpSpPr>
+        <a:xfrm>
+          <a:off x="0" y="0"/>
+          <a:ext cx="0" cy="0"/>
+          <a:chOff x="0" y="0"/>
+          <a:chExt cx="0" cy="0"/>
+        </a:xfrm>
+      </p:grpSpPr>
+      <p:sp>
+        <p:nvSpPr>
+          <p:cNvPr id="2" name="Shape 0">
+            <a:extLst>
+              <a:ext uri="{FF2B5EF4-FFF2-40B4-BE49-F238E27FC236}">
+                <a16:creationId xmlns:a16="http://schemas.microsoft.com/office/drawing/2014/main" id="{71B55D49-3F87-D6B4-1363-1FD5BC867C71}"/>
+              </a:ext>
+            </a:extLst>
+          </p:cNvPr>
+          <p:cNvSpPr/>
+          <p:nvPr/>
+        </p:nvSpPr>
+        <p:spPr>
+          <a:xfrm>
+            <a:off x="0" y="0"/>
+            <a:ext cx="9144000" cy="109728"/>
+          </a:xfrm>
+          <a:prstGeom prst="rect">
+            <a:avLst/>
+          </a:prstGeom>
+          <a:solidFill>
+            <a:srgbClr val="6C4CF1"/>
+          </a:solidFill>
+          <a:ln w="12700">
+            <a:solidFill>
+              <a:srgbClr val="6C4CF1"/>
+            </a:solidFill>
+            <a:prstDash val="solid"/>
+          </a:ln>
+        </p:spPr>
+        <p:txBody>
+          <a:bodyPr/>
+          <a:lstStyle/>
+          <a:p>
+            <a:endParaRPr lang="en-US"/>
+          </a:p>
+        </p:txBody>
+      </p:sp>
+      <p:sp>
+        <p:nvSpPr>
+          <p:cNvPr id="3" name="Text 1">
+            <a:extLst>
+              <a:ext uri="{FF2B5EF4-FFF2-40B4-BE49-F238E27FC236}">
+                <a16:creationId xmlns:a16="http://schemas.microsoft.com/office/drawing/2014/main" id="{7CA4A122-AAFE-4AC8-4DAE-84AABABB032C}"/>
+              </a:ext>
+            </a:extLst>
+          </p:cNvPr>
+          <p:cNvSpPr/>
+          <p:nvPr/>
+        </p:nvSpPr>
+        <p:spPr>
+          <a:xfrm>
+            <a:off x="457200" y="274320"/>
+            <a:ext cx="8229600" cy="548640"/>
+          </a:xfrm>
+          <a:prstGeom prst="rect">
+            <a:avLst/>
+          </a:prstGeom>
+          <a:noFill/>
+          <a:ln/>
+        </p:spPr>
+        <p:txBody>
+          <a:bodyPr wrap="square" lIns="0" tIns="0" rIns="0" bIns="0" rtlCol="0" anchor="ctr"/>
+          <a:lstStyle/>
+          <a:p>
+            <a:pPr marL="0" indent="0">
+              <a:buNone/>
+            </a:pPr>
+            <a:r>
+              <a:rPr lang="en-US" sz="2800" b="1" dirty="0">
+                <a:solidFill>
+                  <a:srgbClr val="1F2238"/>
+                </a:solidFill>
+                <a:latin typeface="Calibri" pitchFamily="34" charset="0"/>
+                <a:ea typeface="Calibri" pitchFamily="34" charset="-122"/>
+                <a:cs typeface="Calibri" pitchFamily="34" charset="-120"/>
+              </a:rPr>
+              <a:t>Vulnerability analysis (preliminary)</a:t>
+            </a:r>
+            <a:endParaRPr lang="en-US" sz="2800" dirty="0"/>
+          </a:p>
+        </p:txBody>
+      </p:sp>
+      <p:sp>
+        <p:nvSpPr>
+          <p:cNvPr id="4" name="Text 2">
+            <a:extLst>
+              <a:ext uri="{FF2B5EF4-FFF2-40B4-BE49-F238E27FC236}">
+                <a16:creationId xmlns:a16="http://schemas.microsoft.com/office/drawing/2014/main" id="{040B24EE-68DF-DD0B-41BD-EAEC4DCF351A}"/>
+              </a:ext>
+            </a:extLst>
+          </p:cNvPr>
+          <p:cNvSpPr/>
+          <p:nvPr/>
+        </p:nvSpPr>
+        <p:spPr>
+          <a:xfrm>
+            <a:off x="457200" y="804672"/>
+            <a:ext cx="8229600" cy="320040"/>
+          </a:xfrm>
+          <a:prstGeom prst="rect">
+            <a:avLst/>
+          </a:prstGeom>
+          <a:noFill/>
+          <a:ln/>
+        </p:spPr>
+        <p:txBody>
+          <a:bodyPr wrap="square" lIns="0" tIns="0" rIns="0" bIns="0" rtlCol="0" anchor="ctr"/>
+          <a:lstStyle/>
+          <a:p>
+            <a:pPr marL="0" indent="0">
+              <a:buNone/>
+            </a:pPr>
+            <a:r>
+              <a:rPr lang="en-US" sz="1400" dirty="0">
+                <a:solidFill>
+                  <a:srgbClr val="6B7088"/>
+                </a:solidFill>
+                <a:latin typeface="Calibri" pitchFamily="34" charset="0"/>
+                <a:ea typeface="Calibri" pitchFamily="34" charset="-122"/>
+                <a:cs typeface="Calibri" pitchFamily="34" charset="-120"/>
+              </a:rPr>
+              <a:t>npm audit + manual probing of the HTTPS API – reported, not yet fixed</a:t>
+            </a:r>
+            <a:endParaRPr lang="en-US" sz="1400" dirty="0"/>
+          </a:p>
+        </p:txBody>
+      </p:sp>
+      <p:sp>
+        <p:nvSpPr>
+          <p:cNvPr id="7" name="TextBox 6">
+            <a:extLst>
+              <a:ext uri="{FF2B5EF4-FFF2-40B4-BE49-F238E27FC236}">
+                <a16:creationId xmlns:a16="http://schemas.microsoft.com/office/drawing/2014/main" id="{CA5452FF-4031-1BB8-69BC-891B4DF41B74}"/>
+              </a:ext>
+            </a:extLst>
+          </p:cNvPr>
+          <p:cNvSpPr txBox="1"/>
+          <p:nvPr/>
+        </p:nvSpPr>
+        <p:spPr>
+          <a:xfrm>
+            <a:off x="3000533" y="4603663"/>
+            <a:ext cx="3142929" cy="338554"/>
+          </a:xfrm>
+          <a:prstGeom prst="rect">
+            <a:avLst/>
+          </a:prstGeom>
+          <a:noFill/>
+        </p:spPr>
+        <p:txBody>
+          <a:bodyPr wrap="square" rtlCol="0">
+            <a:spAutoFit/>
+          </a:bodyPr>
+          <a:lstStyle/>
+          <a:p>
+            <a:pPr algn="ctr"/>
+            <a:r>
+              <a:rPr lang="en-US" sz="1600" dirty="0" err="1"/>
+              <a:t>Snyk</a:t>
+            </a:r>
+            <a:r>
+              <a:rPr lang="en-US" sz="1600" dirty="0"/>
+              <a:t> Report</a:t>
+            </a:r>
+          </a:p>
+        </p:txBody>
+      </p:sp>
+      <p:pic>
+        <p:nvPicPr>
+          <p:cNvPr id="8" name="Picture 7">
+            <a:extLst>
+              <a:ext uri="{FF2B5EF4-FFF2-40B4-BE49-F238E27FC236}">
+                <a16:creationId xmlns:a16="http://schemas.microsoft.com/office/drawing/2014/main" id="{5D1C1B51-A728-9620-9096-577F46C5C1E5}"/>
+              </a:ext>
+            </a:extLst>
+          </p:cNvPr>
+          <p:cNvPicPr>
+            <a:picLocks noChangeAspect="1"/>
+          </p:cNvPicPr>
+          <p:nvPr/>
+        </p:nvPicPr>
+        <p:blipFill>
+          <a:blip r:embed="rId3"/>
+          <a:stretch>
+            <a:fillRect/>
+          </a:stretch>
+        </p:blipFill>
+        <p:spPr>
+          <a:xfrm>
+            <a:off x="2529588" y="1207870"/>
+            <a:ext cx="4084820" cy="3357120"/>
+          </a:xfrm>
+          <a:prstGeom prst="rect">
+            <a:avLst/>
+          </a:prstGeom>
+        </p:spPr>
+      </p:pic>
+    </p:spTree>
+    <p:extLst>
+      <p:ext uri="{BB962C8B-B14F-4D97-AF65-F5344CB8AC3E}">
+        <p14:creationId xmlns:p14="http://schemas.microsoft.com/office/powerpoint/2010/main" val="4284757814"/>
+      </p:ext>
+    </p:extLst>
+  </p:cSld>
+  <p:clrMapOvr>
+    <a:masterClrMapping/>
+  </p:clrMapOvr>
+</p:sld>
+</file>
+
+<file path=ppt/slides/slide12.xml><?xml version="1.0" encoding="utf-8"?>
 <p:sld xmlns:a="http://schemas.openxmlformats.org/drawingml/2006/main" xmlns:r="http://schemas.openxmlformats.org/officeDocument/2006/relationships" xmlns:p="http://schemas.openxmlformats.org/presentationml/2006/main">
   <p:cSld name="Slide 10">
     <p:bg>

</xml_diff>

<commit_message>
Updated presentation with github insights
</commit_message>
<xml_diff>
--- a/presentation/MoodStreak.pptx
+++ b/presentation/MoodStreak.pptx
@@ -5,7 +5,7 @@
     <p:sldMasterId id="2147483648" r:id="rId1"/>
   </p:sldMasterIdLst>
   <p:notesMasterIdLst>
-    <p:notesMasterId r:id="rId14"/>
+    <p:notesMasterId r:id="rId15"/>
   </p:notesMasterIdLst>
   <p:sldIdLst>
     <p:sldId id="256" r:id="rId2"/>
@@ -20,6 +20,7 @@
     <p:sldId id="266" r:id="rId11"/>
     <p:sldId id="267" r:id="rId12"/>
     <p:sldId id="265" r:id="rId13"/>
+    <p:sldId id="268" r:id="rId14"/>
   </p:sldIdLst>
   <p:sldSz cx="9144000" cy="5143500" type="screen16x9"/>
   <p:notesSz cx="5143500" cy="9144000"/>
@@ -623,6 +624,114 @@
     <p:extLst>
       <p:ext uri="{BB962C8B-B14F-4D97-AF65-F5344CB8AC3E}">
         <p14:creationId xmlns:p14="http://schemas.microsoft.com/office/powerpoint/2010/main" val="1024086991"/>
+      </p:ext>
+    </p:extLst>
+  </p:cSld>
+  <p:clrMapOvr>
+    <a:masterClrMapping/>
+  </p:clrMapOvr>
+</p:notes>
+</file>
+
+<file path=ppt/notesSlides/notesSlide13.xml><?xml version="1.0" encoding="utf-8"?>
+<p:notes xmlns:a="http://schemas.openxmlformats.org/drawingml/2006/main" xmlns:r="http://schemas.openxmlformats.org/officeDocument/2006/relationships" xmlns:p="http://schemas.openxmlformats.org/presentationml/2006/main">
+  <p:cSld>
+    <p:spTree>
+      <p:nvGrpSpPr>
+        <p:cNvPr id="1" name="">
+          <a:extLst>
+            <a:ext uri="{FF2B5EF4-FFF2-40B4-BE49-F238E27FC236}">
+              <a16:creationId xmlns:a16="http://schemas.microsoft.com/office/drawing/2014/main" id="{57A2A30D-28A3-603C-85F9-5363CBEAB7BB}"/>
+            </a:ext>
+          </a:extLst>
+        </p:cNvPr>
+        <p:cNvGrpSpPr/>
+        <p:nvPr/>
+      </p:nvGrpSpPr>
+      <p:grpSpPr>
+        <a:xfrm>
+          <a:off x="0" y="0"/>
+          <a:ext cx="0" cy="0"/>
+          <a:chOff x="0" y="0"/>
+          <a:chExt cx="0" cy="0"/>
+        </a:xfrm>
+      </p:grpSpPr>
+      <p:sp>
+        <p:nvSpPr>
+          <p:cNvPr id="2" name="Slide Image Placeholder 1">
+            <a:extLst>
+              <a:ext uri="{FF2B5EF4-FFF2-40B4-BE49-F238E27FC236}">
+                <a16:creationId xmlns:a16="http://schemas.microsoft.com/office/drawing/2014/main" id="{DBB4C1FC-117B-2FF1-0B86-9173B3802617}"/>
+              </a:ext>
+            </a:extLst>
+          </p:cNvPr>
+          <p:cNvSpPr>
+            <a:spLocks noGrp="1" noRot="1" noChangeAspect="1"/>
+          </p:cNvSpPr>
+          <p:nvPr>
+            <p:ph type="sldImg"/>
+          </p:nvPr>
+        </p:nvSpPr>
+        <p:spPr/>
+      </p:sp>
+      <p:sp>
+        <p:nvSpPr>
+          <p:cNvPr id="3" name="Notes Placeholder 2">
+            <a:extLst>
+              <a:ext uri="{FF2B5EF4-FFF2-40B4-BE49-F238E27FC236}">
+                <a16:creationId xmlns:a16="http://schemas.microsoft.com/office/drawing/2014/main" id="{4C4386FF-47AF-D4DC-70A7-5FBE60A387A7}"/>
+              </a:ext>
+            </a:extLst>
+          </p:cNvPr>
+          <p:cNvSpPr>
+            <a:spLocks noGrp="1"/>
+          </p:cNvSpPr>
+          <p:nvPr>
+            <p:ph type="body" idx="1"/>
+          </p:nvPr>
+        </p:nvSpPr>
+        <p:spPr/>
+        <p:txBody>
+          <a:bodyPr/>
+          <a:lstStyle/>
+          <a:p>
+            <a:endParaRPr lang="en-US" dirty="0"/>
+          </a:p>
+        </p:txBody>
+      </p:sp>
+      <p:sp>
+        <p:nvSpPr>
+          <p:cNvPr id="4" name="Slide Number Placeholder 3">
+            <a:extLst>
+              <a:ext uri="{FF2B5EF4-FFF2-40B4-BE49-F238E27FC236}">
+                <a16:creationId xmlns:a16="http://schemas.microsoft.com/office/drawing/2014/main" id="{E05BA94B-0AEB-68DB-0F05-842EE84B5444}"/>
+              </a:ext>
+            </a:extLst>
+          </p:cNvPr>
+          <p:cNvSpPr>
+            <a:spLocks noGrp="1"/>
+          </p:cNvSpPr>
+          <p:nvPr>
+            <p:ph type="sldNum" sz="quarter" idx="10"/>
+          </p:nvPr>
+        </p:nvSpPr>
+        <p:spPr/>
+        <p:txBody>
+          <a:bodyPr/>
+          <a:lstStyle/>
+          <a:p>
+            <a:fld id="{F7021451-1387-4CA6-816F-3879F97B5CBC}" type="slidenum">
+              <a:rPr lang="en-US"/>
+              <a:t>13</a:t>
+            </a:fld>
+            <a:endParaRPr lang="en-US"/>
+          </a:p>
+        </p:txBody>
+      </p:sp>
+    </p:spTree>
+    <p:extLst>
+      <p:ext uri="{BB962C8B-B14F-4D97-AF65-F5344CB8AC3E}">
+        <p14:creationId xmlns:p14="http://schemas.microsoft.com/office/powerpoint/2010/main" val="2348826050"/>
       </p:ext>
     </p:extLst>
   </p:cSld>
@@ -2763,6 +2872,223 @@
         </p:txBody>
       </p:sp>
     </p:spTree>
+  </p:cSld>
+  <p:clrMapOvr>
+    <a:masterClrMapping/>
+  </p:clrMapOvr>
+</p:sld>
+</file>
+
+<file path=ppt/slides/slide13.xml><?xml version="1.0" encoding="utf-8"?>
+<p:sld xmlns:a="http://schemas.openxmlformats.org/drawingml/2006/main" xmlns:r="http://schemas.openxmlformats.org/officeDocument/2006/relationships" xmlns:p="http://schemas.openxmlformats.org/presentationml/2006/main">
+  <p:cSld>
+    <p:bg>
+      <p:bgPr>
+        <a:solidFill>
+          <a:srgbClr val="FFFFFF"/>
+        </a:solidFill>
+        <a:effectLst/>
+      </p:bgPr>
+    </p:bg>
+    <p:spTree>
+      <p:nvGrpSpPr>
+        <p:cNvPr id="1" name="">
+          <a:extLst>
+            <a:ext uri="{FF2B5EF4-FFF2-40B4-BE49-F238E27FC236}">
+              <a16:creationId xmlns:a16="http://schemas.microsoft.com/office/drawing/2014/main" id="{2B303ED1-65A0-5FD6-2C81-5FE61F8E42A6}"/>
+            </a:ext>
+          </a:extLst>
+        </p:cNvPr>
+        <p:cNvGrpSpPr/>
+        <p:nvPr/>
+      </p:nvGrpSpPr>
+      <p:grpSpPr>
+        <a:xfrm>
+          <a:off x="0" y="0"/>
+          <a:ext cx="0" cy="0"/>
+          <a:chOff x="0" y="0"/>
+          <a:chExt cx="0" cy="0"/>
+        </a:xfrm>
+      </p:grpSpPr>
+      <p:sp>
+        <p:nvSpPr>
+          <p:cNvPr id="2" name="Shape 0">
+            <a:extLst>
+              <a:ext uri="{FF2B5EF4-FFF2-40B4-BE49-F238E27FC236}">
+                <a16:creationId xmlns:a16="http://schemas.microsoft.com/office/drawing/2014/main" id="{CB4F85AB-6739-2D2A-5916-62DFE7EDADF9}"/>
+              </a:ext>
+            </a:extLst>
+          </p:cNvPr>
+          <p:cNvSpPr/>
+          <p:nvPr/>
+        </p:nvSpPr>
+        <p:spPr>
+          <a:xfrm>
+            <a:off x="0" y="0"/>
+            <a:ext cx="9144000" cy="109728"/>
+          </a:xfrm>
+          <a:prstGeom prst="rect">
+            <a:avLst/>
+          </a:prstGeom>
+          <a:solidFill>
+            <a:srgbClr val="6C4CF1"/>
+          </a:solidFill>
+          <a:ln w="12700">
+            <a:solidFill>
+              <a:srgbClr val="6C4CF1"/>
+            </a:solidFill>
+            <a:prstDash val="solid"/>
+          </a:ln>
+        </p:spPr>
+        <p:txBody>
+          <a:bodyPr/>
+          <a:lstStyle/>
+          <a:p>
+            <a:endParaRPr lang="en-US"/>
+          </a:p>
+        </p:txBody>
+      </p:sp>
+      <p:sp>
+        <p:nvSpPr>
+          <p:cNvPr id="3" name="Text 1">
+            <a:extLst>
+              <a:ext uri="{FF2B5EF4-FFF2-40B4-BE49-F238E27FC236}">
+                <a16:creationId xmlns:a16="http://schemas.microsoft.com/office/drawing/2014/main" id="{8CC7F538-B073-D026-9B30-D037E19C2FF1}"/>
+              </a:ext>
+            </a:extLst>
+          </p:cNvPr>
+          <p:cNvSpPr/>
+          <p:nvPr/>
+        </p:nvSpPr>
+        <p:spPr>
+          <a:xfrm>
+            <a:off x="457200" y="274320"/>
+            <a:ext cx="8229600" cy="548640"/>
+          </a:xfrm>
+          <a:prstGeom prst="rect">
+            <a:avLst/>
+          </a:prstGeom>
+          <a:noFill/>
+          <a:ln/>
+        </p:spPr>
+        <p:txBody>
+          <a:bodyPr wrap="square" lIns="0" tIns="0" rIns="0" bIns="0" rtlCol="0" anchor="ctr"/>
+          <a:lstStyle/>
+          <a:p>
+            <a:pPr marL="0" indent="0">
+              <a:buNone/>
+            </a:pPr>
+            <a:r>
+              <a:rPr lang="en-US" sz="2800" b="1" dirty="0">
+                <a:solidFill>
+                  <a:srgbClr val="1F2238"/>
+                </a:solidFill>
+                <a:latin typeface="Calibri" pitchFamily="34" charset="0"/>
+                <a:ea typeface="Calibri" pitchFamily="34" charset="-122"/>
+                <a:cs typeface="Calibri" pitchFamily="34" charset="-120"/>
+              </a:rPr>
+              <a:t>GitHub Insights</a:t>
+            </a:r>
+            <a:endParaRPr lang="en-US" sz="2800" dirty="0"/>
+          </a:p>
+        </p:txBody>
+      </p:sp>
+      <p:pic>
+        <p:nvPicPr>
+          <p:cNvPr id="11" name="Picture 10">
+            <a:extLst>
+              <a:ext uri="{FF2B5EF4-FFF2-40B4-BE49-F238E27FC236}">
+                <a16:creationId xmlns:a16="http://schemas.microsoft.com/office/drawing/2014/main" id="{BA023989-CBE4-7566-41F2-FE5C03A151EF}"/>
+              </a:ext>
+            </a:extLst>
+          </p:cNvPr>
+          <p:cNvPicPr>
+            <a:picLocks noChangeAspect="1"/>
+          </p:cNvPicPr>
+          <p:nvPr/>
+        </p:nvPicPr>
+        <p:blipFill>
+          <a:blip r:embed="rId3"/>
+          <a:stretch>
+            <a:fillRect/>
+          </a:stretch>
+        </p:blipFill>
+        <p:spPr>
+          <a:xfrm>
+            <a:off x="457200" y="1027106"/>
+            <a:ext cx="4204741" cy="3089287"/>
+          </a:xfrm>
+          <a:prstGeom prst="rect">
+            <a:avLst/>
+          </a:prstGeom>
+        </p:spPr>
+      </p:pic>
+      <p:pic>
+        <p:nvPicPr>
+          <p:cNvPr id="13" name="Picture 12">
+            <a:extLst>
+              <a:ext uri="{FF2B5EF4-FFF2-40B4-BE49-F238E27FC236}">
+                <a16:creationId xmlns:a16="http://schemas.microsoft.com/office/drawing/2014/main" id="{03996221-6408-0E3F-3146-D2C06AF6AE1B}"/>
+              </a:ext>
+            </a:extLst>
+          </p:cNvPr>
+          <p:cNvPicPr>
+            <a:picLocks noChangeAspect="1"/>
+          </p:cNvPicPr>
+          <p:nvPr/>
+        </p:nvPicPr>
+        <p:blipFill>
+          <a:blip r:embed="rId4"/>
+          <a:stretch>
+            <a:fillRect/>
+          </a:stretch>
+        </p:blipFill>
+        <p:spPr>
+          <a:xfrm>
+            <a:off x="4918051" y="548640"/>
+            <a:ext cx="3768749" cy="2420861"/>
+          </a:xfrm>
+          <a:prstGeom prst="rect">
+            <a:avLst/>
+          </a:prstGeom>
+        </p:spPr>
+      </p:pic>
+      <p:pic>
+        <p:nvPicPr>
+          <p:cNvPr id="15" name="Picture 14">
+            <a:extLst>
+              <a:ext uri="{FF2B5EF4-FFF2-40B4-BE49-F238E27FC236}">
+                <a16:creationId xmlns:a16="http://schemas.microsoft.com/office/drawing/2014/main" id="{735D7C08-E2D7-206D-D7FD-4D714DBBBF90}"/>
+              </a:ext>
+            </a:extLst>
+          </p:cNvPr>
+          <p:cNvPicPr>
+            <a:picLocks noChangeAspect="1"/>
+          </p:cNvPicPr>
+          <p:nvPr/>
+        </p:nvPicPr>
+        <p:blipFill>
+          <a:blip r:embed="rId5"/>
+          <a:stretch>
+            <a:fillRect/>
+          </a:stretch>
+        </p:blipFill>
+        <p:spPr>
+          <a:xfrm>
+            <a:off x="4918051" y="2450892"/>
+            <a:ext cx="3768749" cy="2420861"/>
+          </a:xfrm>
+          <a:prstGeom prst="rect">
+            <a:avLst/>
+          </a:prstGeom>
+        </p:spPr>
+      </p:pic>
+    </p:spTree>
+    <p:extLst>
+      <p:ext uri="{BB962C8B-B14F-4D97-AF65-F5344CB8AC3E}">
+        <p14:creationId xmlns:p14="http://schemas.microsoft.com/office/powerpoint/2010/main" val="893409203"/>
+      </p:ext>
+    </p:extLst>
   </p:cSld>
   <p:clrMapOvr>
     <a:masterClrMapping/>

</xml_diff>